<commit_message>
Add card grid, banner layout, and visual hierarchy improvements
- New ::cards syntax for multi-column card grid with colored icons
- New >> syntax for bottom summary banner
- Update slides_p10_p12.md to use new visual layouts
- Based on cognitive science: chunking, pre-attentive attributes, Gestalt grouping

https://claude.ai/code/session_0131QRdg3FhyRqD7kn6YfEQ8
</commit_message>
<xml_diff>
--- a/slides_p10_p12.pptx
+++ b/slides_p10_p12.pptx
@@ -3241,338 +3241,27 @@
                 </a:solidFill>
                 <a:latin typeface="Meiryo UI"/>
               </a:rPr>
-              <a:t>FY28売上900億円の道筋は明確。SaaS・AI・M&amp;Aの3本柱でTAMを5倍に拡大する。</a:t>
-            </a:r>
-          </a:p>
-        </p:txBody>
-      </p:sp>
-      <p:graphicFrame>
-        <p:nvGraphicFramePr>
-          <p:cNvPr id="6" name="Table 5"/>
-          <p:cNvGraphicFramePr>
-            <a:graphicFrameLocks noGrp="1"/>
-          </p:cNvGraphicFramePr>
-          <p:nvPr/>
-        </p:nvGraphicFramePr>
-        <p:xfrm>
-          <a:off x="838504" y="1280160"/>
-          <a:ext cx="10515600" cy="2437332"/>
-        </p:xfrm>
-        <a:graphic>
-          <a:graphicData uri="http://schemas.openxmlformats.org/drawingml/2006/table">
-            <a:tbl>
-              <a:tblPr firstRow="1" bandRow="1">
-                <a:tableStyleId>{5C22544A-7EE6-4342-B048-85BDC9FD1C3A}</a:tableStyleId>
-              </a:tblPr>
-              <a:tblGrid>
-                <a:gridCol w="3505200"/>
-                <a:gridCol w="3505200"/>
-                <a:gridCol w="3505200"/>
-              </a:tblGrid>
-              <a:tr h="365760">
-                <a:tc>
-                  <a:txBody>
-                    <a:bodyPr wrap="square"/>
-                    <a:lstStyle/>
-                    <a:p>
-                      <a:pPr algn="ctr"/>
-                      <a:r>
-                        <a:rPr sz="1400" b="1" i="0">
-                          <a:solidFill>
-                            <a:srgbClr val="FFFFFF"/>
-                          </a:solidFill>
-                          <a:latin typeface="Meiryo UI"/>
-                        </a:rPr>
-                        <a:t>柱</a:t>
-                      </a:r>
-                    </a:p>
-                  </a:txBody>
-                  <a:tcPr>
-                    <a:solidFill>
-                      <a:srgbClr val="1D3461"/>
-                    </a:solidFill>
-                  </a:tcPr>
-                </a:tc>
-                <a:tc>
-                  <a:txBody>
-                    <a:bodyPr wrap="square"/>
-                    <a:lstStyle/>
-                    <a:p>
-                      <a:pPr algn="ctr"/>
-                      <a:r>
-                        <a:rPr sz="1400" b="1" i="0">
-                          <a:solidFill>
-                            <a:srgbClr val="FFFFFF"/>
-                          </a:solidFill>
-                          <a:latin typeface="Meiryo UI"/>
-                        </a:rPr>
-                        <a:t>戦略の核心</a:t>
-                      </a:r>
-                    </a:p>
-                  </a:txBody>
-                  <a:tcPr>
-                    <a:solidFill>
-                      <a:srgbClr val="1D3461"/>
-                    </a:solidFill>
-                  </a:tcPr>
-                </a:tc>
-                <a:tc>
-                  <a:txBody>
-                    <a:bodyPr wrap="square"/>
-                    <a:lstStyle/>
-                    <a:p>
-                      <a:pPr algn="ctr"/>
-                      <a:r>
-                        <a:rPr sz="1400" b="1" i="0">
-                          <a:solidFill>
-                            <a:srgbClr val="FFFFFF"/>
-                          </a:solidFill>
-                          <a:latin typeface="Meiryo UI"/>
-                        </a:rPr>
-                        <a:t>目指す状態</a:t>
-                      </a:r>
-                    </a:p>
-                  </a:txBody>
-                  <a:tcPr>
-                    <a:solidFill>
-                      <a:srgbClr val="1D3461"/>
-                    </a:solidFill>
-                  </a:tcPr>
-                </a:tc>
-              </a:tr>
-              <a:tr h="690524">
-                <a:tc>
-                  <a:txBody>
-                    <a:bodyPr wrap="square"/>
-                    <a:lstStyle/>
-                    <a:p>
-                      <a:pPr algn="l"/>
-                      <a:r>
-                        <a:rPr sz="1400" b="0" i="0">
-                          <a:solidFill>
-                            <a:srgbClr val="1A1A1A"/>
-                          </a:solidFill>
-                          <a:latin typeface="Meiryo UI"/>
-                        </a:rPr>
-                        <a:t>SaaS：バックオフィス価値向上</a:t>
-                      </a:r>
-                    </a:p>
-                  </a:txBody>
-                  <a:tcPr>
-                    <a:solidFill>
-                      <a:srgbClr val="F5F7FA"/>
-                    </a:solidFill>
-                  </a:tcPr>
-                </a:tc>
-                <a:tc>
-                  <a:txBody>
-                    <a:bodyPr wrap="square"/>
-                    <a:lstStyle/>
-                    <a:p>
-                      <a:pPr algn="l"/>
-                      <a:r>
-                        <a:rPr sz="1400" b="0" i="0">
-                          <a:solidFill>
-                            <a:srgbClr val="1A1A1A"/>
-                          </a:solidFill>
-                          <a:latin typeface="Meiryo UI"/>
-                        </a:rPr>
-                        <a:t>60超プロダクトで会計・人事・法務を網羅</a:t>
-                      </a:r>
-                    </a:p>
-                  </a:txBody>
-                  <a:tcPr>
-                    <a:solidFill>
-                      <a:srgbClr val="F5F7FA"/>
-                    </a:solidFill>
-                  </a:tcPr>
-                </a:tc>
-                <a:tc>
-                  <a:txBody>
-                    <a:bodyPr wrap="square"/>
-                    <a:lstStyle/>
-                    <a:p>
-                      <a:pPr algn="l"/>
-                      <a:r>
-                        <a:rPr sz="1400" b="0" i="0">
-                          <a:solidFill>
-                            <a:srgbClr val="1A1A1A"/>
-                          </a:solidFill>
-                          <a:latin typeface="Meiryo UI"/>
-                        </a:rPr>
-                        <a:t>顧客基盤拡大とARPA向上</a:t>
-                      </a:r>
-                    </a:p>
-                  </a:txBody>
-                  <a:tcPr>
-                    <a:solidFill>
-                      <a:srgbClr val="F5F7FA"/>
-                    </a:solidFill>
-                  </a:tcPr>
-                </a:tc>
-              </a:tr>
-              <a:tr h="690524">
-                <a:tc>
-                  <a:txBody>
-                    <a:bodyPr wrap="square"/>
-                    <a:lstStyle/>
-                    <a:p>
-                      <a:pPr algn="l"/>
-                      <a:r>
-                        <a:rPr sz="1400" b="0" i="0">
-                          <a:solidFill>
-                            <a:srgbClr val="1A1A1A"/>
-                          </a:solidFill>
-                          <a:latin typeface="Meiryo UI"/>
-                        </a:rPr>
-                        <a:t>AI：AIプロダクト開発・提供</a:t>
-                      </a:r>
-                    </a:p>
-                  </a:txBody>
-                  <a:tcPr>
-                    <a:solidFill>
-                      <a:srgbClr val="FFFFFF"/>
-                    </a:solidFill>
-                  </a:tcPr>
-                </a:tc>
-                <a:tc>
-                  <a:txBody>
-                    <a:bodyPr wrap="square"/>
-                    <a:lstStyle/>
-                    <a:p>
-                      <a:pPr algn="l"/>
-                      <a:r>
-                        <a:rPr sz="1400" b="0" i="0">
-                          <a:solidFill>
-                            <a:srgbClr val="1A1A1A"/>
-                          </a:solidFill>
-                          <a:latin typeface="Meiryo UI"/>
-                        </a:rPr>
-                        <a:t>AIエージェント・AIネイティブ・AI×BPO</a:t>
-                      </a:r>
-                    </a:p>
-                  </a:txBody>
-                  <a:tcPr>
-                    <a:solidFill>
-                      <a:srgbClr val="FFFFFF"/>
-                    </a:solidFill>
-                  </a:tcPr>
-                </a:tc>
-                <a:tc>
-                  <a:txBody>
-                    <a:bodyPr wrap="square"/>
-                    <a:lstStyle/>
-                    <a:p>
-                      <a:pPr algn="l"/>
-                      <a:r>
-                        <a:rPr sz="1400" b="0" i="0">
-                          <a:solidFill>
-                            <a:srgbClr val="1A1A1A"/>
-                          </a:solidFill>
-                          <a:latin typeface="Meiryo UI"/>
-                        </a:rPr>
-                        <a:t>業務の自律処理</a:t>
-                      </a:r>
-                    </a:p>
-                  </a:txBody>
-                  <a:tcPr>
-                    <a:solidFill>
-                      <a:srgbClr val="FFFFFF"/>
-                    </a:solidFill>
-                  </a:tcPr>
-                </a:tc>
-              </a:tr>
-              <a:tr h="690524">
-                <a:tc>
-                  <a:txBody>
-                    <a:bodyPr wrap="square"/>
-                    <a:lstStyle/>
-                    <a:p>
-                      <a:pPr algn="l"/>
-                      <a:r>
-                        <a:rPr sz="1400" b="0" i="0">
-                          <a:solidFill>
-                            <a:srgbClr val="1A1A1A"/>
-                          </a:solidFill>
-                          <a:latin typeface="Meiryo UI"/>
-                        </a:rPr>
-                        <a:t>M&amp;A：戦略的サービス拡充</a:t>
-                      </a:r>
-                    </a:p>
-                  </a:txBody>
-                  <a:tcPr>
-                    <a:solidFill>
-                      <a:srgbClr val="F5F7FA"/>
-                    </a:solidFill>
-                  </a:tcPr>
-                </a:tc>
-                <a:tc>
-                  <a:txBody>
-                    <a:bodyPr wrap="square"/>
-                    <a:lstStyle/>
-                    <a:p>
-                      <a:pPr algn="l"/>
-                      <a:r>
-                        <a:rPr sz="1400" b="0" i="0">
-                          <a:solidFill>
-                            <a:srgbClr val="1A1A1A"/>
-                          </a:solidFill>
-                          <a:latin typeface="Meiryo UI"/>
-                        </a:rPr>
-                        <a:t>経営管理領域を全方位でカバー</a:t>
-                      </a:r>
-                    </a:p>
-                  </a:txBody>
-                  <a:tcPr>
-                    <a:solidFill>
-                      <a:srgbClr val="F5F7FA"/>
-                    </a:solidFill>
-                  </a:tcPr>
-                </a:tc>
-                <a:tc>
-                  <a:txBody>
-                    <a:bodyPr wrap="square"/>
-                    <a:lstStyle/>
-                    <a:p>
-                      <a:pPr algn="l"/>
-                      <a:r>
-                        <a:rPr sz="1400" b="0" i="0">
-                          <a:solidFill>
-                            <a:srgbClr val="1A1A1A"/>
-                          </a:solidFill>
-                          <a:latin typeface="Meiryo UI"/>
-                        </a:rPr>
-                        <a:t>サービスラインナップ拡充</a:t>
-                      </a:r>
-                    </a:p>
-                  </a:txBody>
-                  <a:tcPr>
-                    <a:solidFill>
-                      <a:srgbClr val="F5F7FA"/>
-                    </a:solidFill>
-                  </a:tcPr>
-                </a:tc>
-              </a:tr>
-            </a:tbl>
-          </a:graphicData>
-        </a:graphic>
-      </p:graphicFrame>
-      <p:sp>
-        <p:nvSpPr>
-          <p:cNvPr id="7" name="Rectangle 6"/>
+              <a:t>貴社の成長戦略は「No.1 Backoffice AI Company」の実現。「SaaS価値向上」「AIプロダクト」「M&amp;A」を3本柱とし、FY28で売上高900億円を目指す。</a:t>
+            </a:r>
+          </a:p>
+        </p:txBody>
+      </p:sp>
+      <p:sp>
+        <p:nvSpPr>
+          <p:cNvPr id="6" name="Rectangle 5"/>
           <p:cNvSpPr/>
           <p:nvPr/>
         </p:nvSpPr>
         <p:spPr>
           <a:xfrm>
-            <a:off x="838504" y="3878020"/>
-            <a:ext cx="10515600" cy="12700"/>
+            <a:off x="838504" y="1280160"/>
+            <a:ext cx="3352800" cy="4408322"/>
           </a:xfrm>
           <a:prstGeom prst="rect">
             <a:avLst/>
           </a:prstGeom>
           <a:solidFill>
-            <a:srgbClr val="CCCCCC"/>
+            <a:srgbClr val="F5F5F5"/>
           </a:solidFill>
           <a:ln>
             <a:noFill/>
@@ -3601,149 +3290,693 @@
           </a:p>
         </p:txBody>
       </p:sp>
-      <p:graphicFrame>
-        <p:nvGraphicFramePr>
-          <p:cNvPr id="8" name="Table 7"/>
-          <p:cNvGraphicFramePr>
-            <a:graphicFrameLocks noGrp="1"/>
-          </p:cNvGraphicFramePr>
+      <p:sp>
+        <p:nvSpPr>
+          <p:cNvPr id="7" name="Rectangle 6"/>
+          <p:cNvSpPr/>
           <p:nvPr/>
-        </p:nvGraphicFramePr>
-        <p:xfrm>
-          <a:off x="838504" y="3991812"/>
-          <a:ext cx="10515600" cy="1463040"/>
-        </p:xfrm>
-        <a:graphic>
-          <a:graphicData uri="http://schemas.openxmlformats.org/drawingml/2006/table">
-            <a:tbl>
-              <a:tblPr firstRow="1" bandRow="1">
-                <a:tableStyleId>{5C22544A-7EE6-4342-B048-85BDC9FD1C3A}</a:tableStyleId>
-              </a:tblPr>
-              <a:tblGrid>
-                <a:gridCol w="5257800"/>
-                <a:gridCol w="5257800"/>
-              </a:tblGrid>
-              <a:tr h="365760">
-                <a:tc>
-                  <a:txBody>
-                    <a:bodyPr wrap="square"/>
-                    <a:lstStyle/>
-                    <a:p>
-                      <a:pPr algn="ctr"/>
-                      <a:r>
-                        <a:rPr sz="1400" b="1" i="0">
-                          <a:solidFill>
-                            <a:srgbClr val="FFFFFF"/>
-                          </a:solidFill>
-                          <a:latin typeface="Meiryo UI"/>
-                        </a:rPr>
-                        <a:t>TAM拡大</a:t>
-                      </a:r>
-                    </a:p>
-                  </a:txBody>
-                  <a:tcPr>
-                    <a:solidFill>
-                      <a:srgbClr val="1D3461"/>
-                    </a:solidFill>
-                  </a:tcPr>
-                </a:tc>
-                <a:tc>
-                  <a:txBody>
-                    <a:bodyPr wrap="square"/>
-                    <a:lstStyle/>
-                    <a:p>
-                      <a:pPr algn="ctr"/>
-                      <a:r>
-                        <a:rPr sz="1400" b="1" i="0">
-                          <a:solidFill>
-                            <a:srgbClr val="FFFFFF"/>
-                          </a:solidFill>
-                          <a:latin typeface="Meiryo UI"/>
-                        </a:rPr>
-                        <a:t>FY28財務目標</a:t>
-                      </a:r>
-                    </a:p>
-                  </a:txBody>
-                  <a:tcPr>
-                    <a:solidFill>
-                      <a:srgbClr val="1D3461"/>
-                    </a:solidFill>
-                  </a:tcPr>
-                </a:tc>
-              </a:tr>
-              <a:tr h="1097280">
-                <a:tc>
-                  <a:txBody>
-                    <a:bodyPr wrap="square"/>
-                    <a:lstStyle/>
-                    <a:p>
-                      <a:pPr algn="l"/>
-                      <a:r>
-                        <a:rPr sz="1400" b="0" i="0">
-                          <a:solidFill>
-                            <a:srgbClr val="1A1A1A"/>
-                          </a:solidFill>
-                          <a:latin typeface="Meiryo UI"/>
-                        </a:rPr>
-                        <a:t>デジタルツール市場 2.8兆円 → </a:t>
-                      </a:r>
-                      <a:r>
-                        <a:rPr sz="1400" b="1" i="0">
-                          <a:solidFill>
-                            <a:srgbClr val="1A1A1A"/>
-                          </a:solidFill>
-                          <a:latin typeface="Meiryo UI"/>
-                        </a:rPr>
-                        <a:t>デジタルワーカー市場 14.1兆円</a:t>
-                      </a:r>
-                      <a:r>
-                        <a:rPr sz="1400" b="0" i="0">
-                          <a:solidFill>
-                            <a:srgbClr val="1A1A1A"/>
-                          </a:solidFill>
-                          <a:latin typeface="Meiryo UI"/>
-                        </a:rPr>
-                        <a:t>（5倍）</a:t>
-                      </a:r>
-                    </a:p>
-                  </a:txBody>
-                  <a:tcPr>
-                    <a:solidFill>
-                      <a:srgbClr val="F5F7FA"/>
-                    </a:solidFill>
-                  </a:tcPr>
-                </a:tc>
-                <a:tc>
-                  <a:txBody>
-                    <a:bodyPr wrap="square"/>
-                    <a:lstStyle/>
-                    <a:p>
-                      <a:pPr algn="l"/>
-                      <a:r>
-                        <a:rPr sz="1400" b="0" i="0">
-                          <a:solidFill>
-                            <a:srgbClr val="1A1A1A"/>
-                          </a:solidFill>
-                          <a:latin typeface="Meiryo UI"/>
-                        </a:rPr>
-                        <a:t>売上900億・EBITDA270億・事業CF180億</a:t>
-                      </a:r>
-                    </a:p>
-                  </a:txBody>
-                  <a:tcPr>
-                    <a:solidFill>
-                      <a:srgbClr val="F5F7FA"/>
-                    </a:solidFill>
-                  </a:tcPr>
-                </a:tc>
-              </a:tr>
-            </a:tbl>
-          </a:graphicData>
-        </a:graphic>
-      </p:graphicFrame>
+        </p:nvSpPr>
+        <p:spPr>
+          <a:xfrm>
+            <a:off x="838504" y="1280160"/>
+            <a:ext cx="3352800" cy="101600"/>
+          </a:xfrm>
+          <a:prstGeom prst="rect">
+            <a:avLst/>
+          </a:prstGeom>
+          <a:solidFill>
+            <a:srgbClr val="0066CD"/>
+          </a:solidFill>
+          <a:ln>
+            <a:noFill/>
+          </a:ln>
+          <a:effectLst/>
+        </p:spPr>
+        <p:style>
+          <a:lnRef idx="1">
+            <a:schemeClr val="accent1"/>
+          </a:lnRef>
+          <a:fillRef idx="3">
+            <a:schemeClr val="accent1"/>
+          </a:fillRef>
+          <a:effectRef idx="2">
+            <a:schemeClr val="accent1"/>
+          </a:effectRef>
+          <a:fontRef idx="minor">
+            <a:schemeClr val="lt1"/>
+          </a:fontRef>
+        </p:style>
+        <p:txBody>
+          <a:bodyPr rtlCol="0" anchor="ctr"/>
+          <a:lstStyle/>
+          <a:p>
+            <a:pPr algn="ctr"/>
+          </a:p>
+        </p:txBody>
+      </p:sp>
+      <p:sp>
+        <p:nvSpPr>
+          <p:cNvPr id="8" name="Oval 7"/>
+          <p:cNvSpPr/>
+          <p:nvPr/>
+        </p:nvSpPr>
+        <p:spPr>
+          <a:xfrm>
+            <a:off x="2286304" y="1518920"/>
+            <a:ext cx="457200" cy="457200"/>
+          </a:xfrm>
+          <a:prstGeom prst="ellipse">
+            <a:avLst/>
+          </a:prstGeom>
+          <a:solidFill>
+            <a:srgbClr val="0066CD"/>
+          </a:solidFill>
+          <a:ln>
+            <a:noFill/>
+          </a:ln>
+          <a:effectLst/>
+        </p:spPr>
+        <p:style>
+          <a:lnRef idx="1">
+            <a:schemeClr val="accent1"/>
+          </a:lnRef>
+          <a:fillRef idx="3">
+            <a:schemeClr val="accent1"/>
+          </a:fillRef>
+          <a:effectRef idx="2">
+            <a:schemeClr val="accent1"/>
+          </a:effectRef>
+          <a:fontRef idx="minor">
+            <a:schemeClr val="lt1"/>
+          </a:fontRef>
+        </p:style>
+        <p:txBody>
+          <a:bodyPr rtlCol="0" anchor="ctr" wrap="none"/>
+          <a:lstStyle/>
+          <a:p>
+            <a:pPr algn="ctr"/>
+            <a:r>
+              <a:rPr sz="1000" b="1" i="0">
+                <a:solidFill>
+                  <a:srgbClr val="FFFFFF"/>
+                </a:solidFill>
+                <a:latin typeface="Meiryo UI"/>
+              </a:rPr>
+              <a:t>SaaS</a:t>
+            </a:r>
+          </a:p>
+        </p:txBody>
+      </p:sp>
+      <p:sp>
+        <p:nvSpPr>
+          <p:cNvPr id="9" name="TextBox 8"/>
+          <p:cNvSpPr txBox="1"/>
+          <p:nvPr/>
+        </p:nvSpPr>
+        <p:spPr>
+          <a:xfrm>
+            <a:off x="948232" y="2067560"/>
+            <a:ext cx="3133344" cy="457200"/>
+          </a:xfrm>
+          <a:prstGeom prst="rect">
+            <a:avLst/>
+          </a:prstGeom>
+          <a:noFill/>
+          <a:effectLst/>
+        </p:spPr>
+        <p:txBody>
+          <a:bodyPr wrap="square">
+            <a:spAutoFit/>
+          </a:bodyPr>
+          <a:lstStyle/>
+          <a:p>
+            <a:pPr algn="ctr"/>
+            <a:r>
+              <a:rPr sz="1400" b="1" i="0">
+                <a:solidFill>
+                  <a:srgbClr val="1A1A1A"/>
+                </a:solidFill>
+                <a:latin typeface="Meiryo UI"/>
+              </a:rPr>
+              <a:t>バックオフィスSaaSの価値向上</a:t>
+            </a:r>
+          </a:p>
+        </p:txBody>
+      </p:sp>
+      <p:sp>
+        <p:nvSpPr>
+          <p:cNvPr id="10" name="TextBox 9"/>
+          <p:cNvSpPr txBox="1"/>
+          <p:nvPr/>
+        </p:nvSpPr>
+        <p:spPr>
+          <a:xfrm>
+            <a:off x="948232" y="2524760"/>
+            <a:ext cx="3133344" cy="3163722"/>
+          </a:xfrm>
+          <a:prstGeom prst="rect">
+            <a:avLst/>
+          </a:prstGeom>
+          <a:noFill/>
+          <a:effectLst/>
+        </p:spPr>
+        <p:txBody>
+          <a:bodyPr wrap="square">
+            <a:spAutoFit/>
+          </a:bodyPr>
+          <a:lstStyle/>
+          <a:p>
+            <a:pPr algn="ctr"/>
+            <a:r>
+              <a:rPr sz="1200" b="0" i="0">
+                <a:solidFill>
+                  <a:srgbClr val="888888"/>
+                </a:solidFill>
+                <a:latin typeface="Meiryo UI"/>
+              </a:rPr>
+              <a:t>60超のプロダクトで会計・人事・法務を網羅。顧客基盤の拡大とARPA向上</a:t>
+            </a:r>
+          </a:p>
+        </p:txBody>
+      </p:sp>
+      <p:sp>
+        <p:nvSpPr>
+          <p:cNvPr id="11" name="Rectangle 10"/>
+          <p:cNvSpPr/>
+          <p:nvPr/>
+        </p:nvSpPr>
+        <p:spPr>
+          <a:xfrm>
+            <a:off x="4419904" y="1280160"/>
+            <a:ext cx="3352800" cy="4408322"/>
+          </a:xfrm>
+          <a:prstGeom prst="rect">
+            <a:avLst/>
+          </a:prstGeom>
+          <a:solidFill>
+            <a:srgbClr val="F5F5F5"/>
+          </a:solidFill>
+          <a:ln>
+            <a:noFill/>
+          </a:ln>
+          <a:effectLst/>
+        </p:spPr>
+        <p:style>
+          <a:lnRef idx="1">
+            <a:schemeClr val="accent1"/>
+          </a:lnRef>
+          <a:fillRef idx="3">
+            <a:schemeClr val="accent1"/>
+          </a:fillRef>
+          <a:effectRef idx="2">
+            <a:schemeClr val="accent1"/>
+          </a:effectRef>
+          <a:fontRef idx="minor">
+            <a:schemeClr val="lt1"/>
+          </a:fontRef>
+        </p:style>
+        <p:txBody>
+          <a:bodyPr rtlCol="0" anchor="ctr"/>
+          <a:lstStyle/>
+          <a:p>
+            <a:pPr algn="ctr"/>
+          </a:p>
+        </p:txBody>
+      </p:sp>
+      <p:sp>
+        <p:nvSpPr>
+          <p:cNvPr id="12" name="Rectangle 11"/>
+          <p:cNvSpPr/>
+          <p:nvPr/>
+        </p:nvSpPr>
+        <p:spPr>
+          <a:xfrm>
+            <a:off x="4419904" y="1280160"/>
+            <a:ext cx="3352800" cy="101600"/>
+          </a:xfrm>
+          <a:prstGeom prst="rect">
+            <a:avLst/>
+          </a:prstGeom>
+          <a:solidFill>
+            <a:srgbClr val="E07F30"/>
+          </a:solidFill>
+          <a:ln>
+            <a:noFill/>
+          </a:ln>
+          <a:effectLst/>
+        </p:spPr>
+        <p:style>
+          <a:lnRef idx="1">
+            <a:schemeClr val="accent1"/>
+          </a:lnRef>
+          <a:fillRef idx="3">
+            <a:schemeClr val="accent1"/>
+          </a:fillRef>
+          <a:effectRef idx="2">
+            <a:schemeClr val="accent1"/>
+          </a:effectRef>
+          <a:fontRef idx="minor">
+            <a:schemeClr val="lt1"/>
+          </a:fontRef>
+        </p:style>
+        <p:txBody>
+          <a:bodyPr rtlCol="0" anchor="ctr"/>
+          <a:lstStyle/>
+          <a:p>
+            <a:pPr algn="ctr"/>
+          </a:p>
+        </p:txBody>
+      </p:sp>
+      <p:sp>
+        <p:nvSpPr>
+          <p:cNvPr id="13" name="Oval 12"/>
+          <p:cNvSpPr/>
+          <p:nvPr/>
+        </p:nvSpPr>
+        <p:spPr>
+          <a:xfrm>
+            <a:off x="5867704" y="1518920"/>
+            <a:ext cx="457200" cy="457200"/>
+          </a:xfrm>
+          <a:prstGeom prst="ellipse">
+            <a:avLst/>
+          </a:prstGeom>
+          <a:solidFill>
+            <a:srgbClr val="E07F30"/>
+          </a:solidFill>
+          <a:ln>
+            <a:noFill/>
+          </a:ln>
+          <a:effectLst/>
+        </p:spPr>
+        <p:style>
+          <a:lnRef idx="1">
+            <a:schemeClr val="accent1"/>
+          </a:lnRef>
+          <a:fillRef idx="3">
+            <a:schemeClr val="accent1"/>
+          </a:fillRef>
+          <a:effectRef idx="2">
+            <a:schemeClr val="accent1"/>
+          </a:effectRef>
+          <a:fontRef idx="minor">
+            <a:schemeClr val="lt1"/>
+          </a:fontRef>
+        </p:style>
+        <p:txBody>
+          <a:bodyPr rtlCol="0" anchor="ctr" wrap="none"/>
+          <a:lstStyle/>
+          <a:p>
+            <a:pPr algn="ctr"/>
+            <a:r>
+              <a:rPr sz="1000" b="1" i="0">
+                <a:solidFill>
+                  <a:srgbClr val="FFFFFF"/>
+                </a:solidFill>
+                <a:latin typeface="Meiryo UI"/>
+              </a:rPr>
+              <a:t>AI</a:t>
+            </a:r>
+          </a:p>
+        </p:txBody>
+      </p:sp>
+      <p:sp>
+        <p:nvSpPr>
+          <p:cNvPr id="14" name="TextBox 13"/>
+          <p:cNvSpPr txBox="1"/>
+          <p:nvPr/>
+        </p:nvSpPr>
+        <p:spPr>
+          <a:xfrm>
+            <a:off x="4529632" y="2067560"/>
+            <a:ext cx="3133344" cy="457200"/>
+          </a:xfrm>
+          <a:prstGeom prst="rect">
+            <a:avLst/>
+          </a:prstGeom>
+          <a:noFill/>
+          <a:effectLst/>
+        </p:spPr>
+        <p:txBody>
+          <a:bodyPr wrap="square">
+            <a:spAutoFit/>
+          </a:bodyPr>
+          <a:lstStyle/>
+          <a:p>
+            <a:pPr algn="ctr"/>
+            <a:r>
+              <a:rPr sz="1400" b="1" i="0">
+                <a:solidFill>
+                  <a:srgbClr val="1A1A1A"/>
+                </a:solidFill>
+                <a:latin typeface="Meiryo UI"/>
+              </a:rPr>
+              <a:t>AIプロダクトの開発・提供</a:t>
+            </a:r>
+          </a:p>
+        </p:txBody>
+      </p:sp>
+      <p:sp>
+        <p:nvSpPr>
+          <p:cNvPr id="15" name="TextBox 14"/>
+          <p:cNvSpPr txBox="1"/>
+          <p:nvPr/>
+        </p:nvSpPr>
+        <p:spPr>
+          <a:xfrm>
+            <a:off x="4529632" y="2524760"/>
+            <a:ext cx="3133344" cy="3163722"/>
+          </a:xfrm>
+          <a:prstGeom prst="rect">
+            <a:avLst/>
+          </a:prstGeom>
+          <a:noFill/>
+          <a:effectLst/>
+        </p:spPr>
+        <p:txBody>
+          <a:bodyPr wrap="square">
+            <a:spAutoFit/>
+          </a:bodyPr>
+          <a:lstStyle/>
+          <a:p>
+            <a:pPr algn="ctr"/>
+            <a:r>
+              <a:rPr sz="1200" b="0" i="0">
+                <a:solidFill>
+                  <a:srgbClr val="888888"/>
+                </a:solidFill>
+                <a:latin typeface="Meiryo UI"/>
+              </a:rPr>
+              <a:t>AIエージェント・AIネイティブプロダクト・AI×BPOで業務を自律処理</a:t>
+            </a:r>
+          </a:p>
+        </p:txBody>
+      </p:sp>
+      <p:sp>
+        <p:nvSpPr>
+          <p:cNvPr id="16" name="Rectangle 15"/>
+          <p:cNvSpPr/>
+          <p:nvPr/>
+        </p:nvSpPr>
+        <p:spPr>
+          <a:xfrm>
+            <a:off x="8001304" y="1280160"/>
+            <a:ext cx="3352800" cy="4408322"/>
+          </a:xfrm>
+          <a:prstGeom prst="rect">
+            <a:avLst/>
+          </a:prstGeom>
+          <a:solidFill>
+            <a:srgbClr val="F5F5F5"/>
+          </a:solidFill>
+          <a:ln>
+            <a:noFill/>
+          </a:ln>
+          <a:effectLst/>
+        </p:spPr>
+        <p:style>
+          <a:lnRef idx="1">
+            <a:schemeClr val="accent1"/>
+          </a:lnRef>
+          <a:fillRef idx="3">
+            <a:schemeClr val="accent1"/>
+          </a:fillRef>
+          <a:effectRef idx="2">
+            <a:schemeClr val="accent1"/>
+          </a:effectRef>
+          <a:fontRef idx="minor">
+            <a:schemeClr val="lt1"/>
+          </a:fontRef>
+        </p:style>
+        <p:txBody>
+          <a:bodyPr rtlCol="0" anchor="ctr"/>
+          <a:lstStyle/>
+          <a:p>
+            <a:pPr algn="ctr"/>
+          </a:p>
+        </p:txBody>
+      </p:sp>
+      <p:sp>
+        <p:nvSpPr>
+          <p:cNvPr id="17" name="Rectangle 16"/>
+          <p:cNvSpPr/>
+          <p:nvPr/>
+        </p:nvSpPr>
+        <p:spPr>
+          <a:xfrm>
+            <a:off x="8001304" y="1280160"/>
+            <a:ext cx="3352800" cy="101600"/>
+          </a:xfrm>
+          <a:prstGeom prst="rect">
+            <a:avLst/>
+          </a:prstGeom>
+          <a:solidFill>
+            <a:srgbClr val="7B61C5"/>
+          </a:solidFill>
+          <a:ln>
+            <a:noFill/>
+          </a:ln>
+          <a:effectLst/>
+        </p:spPr>
+        <p:style>
+          <a:lnRef idx="1">
+            <a:schemeClr val="accent1"/>
+          </a:lnRef>
+          <a:fillRef idx="3">
+            <a:schemeClr val="accent1"/>
+          </a:fillRef>
+          <a:effectRef idx="2">
+            <a:schemeClr val="accent1"/>
+          </a:effectRef>
+          <a:fontRef idx="minor">
+            <a:schemeClr val="lt1"/>
+          </a:fontRef>
+        </p:style>
+        <p:txBody>
+          <a:bodyPr rtlCol="0" anchor="ctr"/>
+          <a:lstStyle/>
+          <a:p>
+            <a:pPr algn="ctr"/>
+          </a:p>
+        </p:txBody>
+      </p:sp>
+      <p:sp>
+        <p:nvSpPr>
+          <p:cNvPr id="18" name="Oval 17"/>
+          <p:cNvSpPr/>
+          <p:nvPr/>
+        </p:nvSpPr>
+        <p:spPr>
+          <a:xfrm>
+            <a:off x="9449104" y="1518920"/>
+            <a:ext cx="457200" cy="457200"/>
+          </a:xfrm>
+          <a:prstGeom prst="ellipse">
+            <a:avLst/>
+          </a:prstGeom>
+          <a:solidFill>
+            <a:srgbClr val="7B61C5"/>
+          </a:solidFill>
+          <a:ln>
+            <a:noFill/>
+          </a:ln>
+          <a:effectLst/>
+        </p:spPr>
+        <p:style>
+          <a:lnRef idx="1">
+            <a:schemeClr val="accent1"/>
+          </a:lnRef>
+          <a:fillRef idx="3">
+            <a:schemeClr val="accent1"/>
+          </a:fillRef>
+          <a:effectRef idx="2">
+            <a:schemeClr val="accent1"/>
+          </a:effectRef>
+          <a:fontRef idx="minor">
+            <a:schemeClr val="lt1"/>
+          </a:fontRef>
+        </p:style>
+        <p:txBody>
+          <a:bodyPr rtlCol="0" anchor="ctr" wrap="none"/>
+          <a:lstStyle/>
+          <a:p>
+            <a:pPr algn="ctr"/>
+            <a:r>
+              <a:rPr sz="1000" b="1" i="0">
+                <a:solidFill>
+                  <a:srgbClr val="FFFFFF"/>
+                </a:solidFill>
+                <a:latin typeface="Meiryo UI"/>
+              </a:rPr>
+              <a:t>M&amp;A</a:t>
+            </a:r>
+          </a:p>
+        </p:txBody>
+      </p:sp>
+      <p:sp>
+        <p:nvSpPr>
+          <p:cNvPr id="19" name="TextBox 18"/>
+          <p:cNvSpPr txBox="1"/>
+          <p:nvPr/>
+        </p:nvSpPr>
+        <p:spPr>
+          <a:xfrm>
+            <a:off x="8111032" y="2067560"/>
+            <a:ext cx="3133344" cy="457200"/>
+          </a:xfrm>
+          <a:prstGeom prst="rect">
+            <a:avLst/>
+          </a:prstGeom>
+          <a:noFill/>
+          <a:effectLst/>
+        </p:spPr>
+        <p:txBody>
+          <a:bodyPr wrap="square">
+            <a:spAutoFit/>
+          </a:bodyPr>
+          <a:lstStyle/>
+          <a:p>
+            <a:pPr algn="ctr"/>
+            <a:r>
+              <a:rPr sz="1400" b="1" i="0">
+                <a:solidFill>
+                  <a:srgbClr val="1A1A1A"/>
+                </a:solidFill>
+                <a:latin typeface="Meiryo UI"/>
+              </a:rPr>
+              <a:t>M&amp;A戦略の遂行</a:t>
+            </a:r>
+          </a:p>
+        </p:txBody>
+      </p:sp>
+      <p:sp>
+        <p:nvSpPr>
+          <p:cNvPr id="20" name="TextBox 19"/>
+          <p:cNvSpPr txBox="1"/>
+          <p:nvPr/>
+        </p:nvSpPr>
+        <p:spPr>
+          <a:xfrm>
+            <a:off x="8111032" y="2524760"/>
+            <a:ext cx="3133344" cy="3163722"/>
+          </a:xfrm>
+          <a:prstGeom prst="rect">
+            <a:avLst/>
+          </a:prstGeom>
+          <a:noFill/>
+          <a:effectLst/>
+        </p:spPr>
+        <p:txBody>
+          <a:bodyPr wrap="square">
+            <a:spAutoFit/>
+          </a:bodyPr>
+          <a:lstStyle/>
+          <a:p>
+            <a:pPr algn="ctr"/>
+            <a:r>
+              <a:rPr sz="1200" b="0" i="0">
+                <a:solidFill>
+                  <a:srgbClr val="888888"/>
+                </a:solidFill>
+                <a:latin typeface="Meiryo UI"/>
+              </a:rPr>
+              <a:t>サービスラインナップ拡充。経営管理領域を全方位でカバーする体制を構築</a:t>
+            </a:r>
+          </a:p>
+        </p:txBody>
+      </p:sp>
+      <p:sp>
+        <p:nvSpPr>
+          <p:cNvPr id="21" name="Rectangle 20"/>
+          <p:cNvSpPr/>
+          <p:nvPr/>
+        </p:nvSpPr>
+        <p:spPr>
+          <a:xfrm>
+            <a:off x="838504" y="5779922"/>
+            <a:ext cx="10515600" cy="502920"/>
+          </a:xfrm>
+          <a:prstGeom prst="rect">
+            <a:avLst/>
+          </a:prstGeom>
+          <a:solidFill>
+            <a:srgbClr val="1D3461"/>
+          </a:solidFill>
+          <a:ln>
+            <a:noFill/>
+          </a:ln>
+          <a:effectLst/>
+        </p:spPr>
+        <p:style>
+          <a:lnRef idx="1">
+            <a:schemeClr val="accent1"/>
+          </a:lnRef>
+          <a:fillRef idx="3">
+            <a:schemeClr val="accent1"/>
+          </a:fillRef>
+          <a:effectRef idx="2">
+            <a:schemeClr val="accent1"/>
+          </a:effectRef>
+          <a:fontRef idx="minor">
+            <a:schemeClr val="lt1"/>
+          </a:fontRef>
+        </p:style>
+        <p:txBody>
+          <a:bodyPr rtlCol="0" anchor="ctr"/>
+          <a:lstStyle/>
+          <a:p>
+            <a:pPr algn="ctr"/>
+          </a:p>
+        </p:txBody>
+      </p:sp>
+      <p:sp>
+        <p:nvSpPr>
+          <p:cNvPr id="22" name="TextBox 21"/>
+          <p:cNvSpPr txBox="1"/>
+          <p:nvPr/>
+        </p:nvSpPr>
+        <p:spPr>
+          <a:xfrm>
+            <a:off x="1021384" y="5779922"/>
+            <a:ext cx="10149840" cy="502920"/>
+          </a:xfrm>
+          <a:prstGeom prst="rect">
+            <a:avLst/>
+          </a:prstGeom>
+          <a:noFill/>
+          <a:effectLst/>
+        </p:spPr>
+        <p:txBody>
+          <a:bodyPr wrap="square">
+            <a:spAutoFit/>
+          </a:bodyPr>
+          <a:lstStyle/>
+          <a:p>
+            <a:pPr algn="ctr"/>
+            <a:r>
+              <a:rPr sz="1400" b="1" i="0">
+                <a:solidFill>
+                  <a:srgbClr val="FFFFFF"/>
+                </a:solidFill>
+                <a:latin typeface="Meiryo UI"/>
+              </a:rPr>
+              <a:t>TAMの5倍拡大：</a:t>
+            </a:r>
+            <a:r>
+              <a:rPr sz="1400" b="0" i="0">
+                <a:solidFill>
+                  <a:srgbClr val="FFFFFF"/>
+                </a:solidFill>
+                <a:latin typeface="Meiryo UI"/>
+              </a:rPr>
+              <a:t> デジタルツール市場（2.8兆円）→ デジタルワーカー市場（14.1兆円）へ　｜　FY28目標：売上900億円以上 / EBITDA270億円以上 / 事業CF180億円以上</a:t>
+            </a:r>
+          </a:p>
+        </p:txBody>
+      </p:sp>
       <p:pic>
         <p:nvPicPr>
-          <p:cNvPr id="9" name="Picture 8" descr="logo.png"/>
+          <p:cNvPr id="23" name="Picture 22" descr="logo.png"/>
           <p:cNvPicPr>
             <a:picLocks noChangeAspect="1"/>
           </p:cNvPicPr>
@@ -3767,7 +4000,7 @@
       </p:pic>
       <p:sp>
         <p:nvSpPr>
-          <p:cNvPr id="10" name="Rectangle 9"/>
+          <p:cNvPr id="24" name="Rectangle 23"/>
           <p:cNvSpPr/>
           <p:nvPr/>
         </p:nvSpPr>
@@ -3811,7 +4044,7 @@
       </p:sp>
       <p:sp>
         <p:nvSpPr>
-          <p:cNvPr id="11" name="TextBox 10"/>
+          <p:cNvPr id="25" name="TextBox 24"/>
           <p:cNvSpPr txBox="1"/>
           <p:nvPr/>
         </p:nvSpPr>
@@ -3845,7 +4078,7 @@
       </p:sp>
       <p:sp>
         <p:nvSpPr>
-          <p:cNvPr id="12" name="TextBox 11"/>
+          <p:cNvPr id="26" name="TextBox 25"/>
           <p:cNvSpPr txBox="1"/>
           <p:nvPr/>
         </p:nvSpPr>
@@ -4041,22 +4274,13 @@
           <a:lstStyle/>
           <a:p>
             <a:r>
-              <a:rPr sz="1800" b="1" i="0">
+              <a:rPr sz="1800" b="0" i="0">
                 <a:solidFill>
                   <a:srgbClr val="1A1A1A"/>
                 </a:solidFill>
                 <a:latin typeface="Meiryo UI"/>
               </a:rPr>
-              <a:t>3つの事象は全て「営業の型が可視化されていない」1点に帰着する。</a:t>
-            </a:r>
-            <a:r>
-              <a:rPr sz="1800" b="0" i="0">
-                <a:solidFill>
-                  <a:srgbClr val="1A1A1A"/>
-                </a:solidFill>
-                <a:latin typeface="Meiryo UI"/>
-              </a:rPr>
-              <a:t> ここを解くと全てが動く。</a:t>
+              <a:t>お電話でお伺いした内容を整理し、貴社固有の課題仮説を立てさせていただきました。合っている・合っていないも含めて率直にお聞かせいただければと思います。</a:t>
             </a:r>
           </a:p>
         </p:txBody>
@@ -4314,14 +4538,14 @@
         </p:nvSpPr>
         <p:spPr>
           <a:xfrm>
-            <a:off x="838504" y="5098288"/>
-            <a:ext cx="10515600" cy="12700"/>
+            <a:off x="838504" y="5779922"/>
+            <a:ext cx="10515600" cy="502920"/>
           </a:xfrm>
           <a:prstGeom prst="rect">
             <a:avLst/>
           </a:prstGeom>
           <a:solidFill>
-            <a:srgbClr val="CCCCCC"/>
+            <a:srgbClr val="1D3461"/>
           </a:solidFill>
           <a:ln>
             <a:noFill/>
@@ -4358,13 +4582,14 @@
         </p:nvSpPr>
         <p:spPr>
           <a:xfrm>
-            <a:off x="838504" y="5199888"/>
-            <a:ext cx="10515600" cy="1064666"/>
+            <a:off x="1021384" y="5779922"/>
+            <a:ext cx="10149840" cy="502920"/>
           </a:xfrm>
           <a:prstGeom prst="rect">
             <a:avLst/>
           </a:prstGeom>
           <a:noFill/>
+          <a:effectLst/>
         </p:spPr>
         <p:txBody>
           <a:bodyPr wrap="square">
@@ -4372,40 +4597,33 @@
           </a:bodyPr>
           <a:lstStyle/>
           <a:p>
-            <a:pPr>
-              <a:spcBef>
-                <a:spcPts val="600"/>
-              </a:spcBef>
-              <a:spcAft>
-                <a:spcPts val="200"/>
-              </a:spcAft>
-            </a:pPr>
-            <a:r>
-              <a:rPr sz="1600" b="0" i="0">
-                <a:solidFill>
-                  <a:srgbClr val="0066CD"/>
-                </a:solidFill>
-                <a:latin typeface="Meiryo UI"/>
-              </a:rPr>
-              <a:t>● </a:t>
-            </a:r>
-            <a:r>
-              <a:rPr sz="1600" b="0" i="0">
-                <a:solidFill>
-                  <a:srgbClr val="1A1A1A"/>
+            <a:pPr algn="ctr"/>
+            <a:r>
+              <a:rPr sz="1400" b="0" i="0">
+                <a:solidFill>
+                  <a:srgbClr val="FFFFFF"/>
                 </a:solidFill>
                 <a:latin typeface="Meiryo UI"/>
               </a:rPr>
               <a:t>3仮説の帰着点：</a:t>
             </a:r>
             <a:r>
-              <a:rPr sz="1600" b="1" i="0">
-                <a:solidFill>
-                  <a:srgbClr val="1A1A1A"/>
+              <a:rPr sz="1400" b="1" i="0">
+                <a:solidFill>
+                  <a:srgbClr val="FFFFFF"/>
                 </a:solidFill>
                 <a:latin typeface="Meiryo UI"/>
               </a:rPr>
               <a:t>「営業の型が可視化されていないこと」</a:t>
+            </a:r>
+            <a:r>
+              <a:rPr sz="1400" b="0" i="0">
+                <a:solidFill>
+                  <a:srgbClr val="FFFFFF"/>
+                </a:solidFill>
+                <a:latin typeface="Meiryo UI"/>
+              </a:rPr>
+              <a:t>。戦略はあるが実行を支える基盤がない</a:t>
             </a:r>
           </a:p>
         </p:txBody>
@@ -4798,7 +5016,7 @@
         <p:spPr>
           <a:xfrm>
             <a:off x="6089954" y="1280160"/>
-            <a:ext cx="12700" cy="2492197"/>
+            <a:ext cx="12700" cy="4408322"/>
           </a:xfrm>
           <a:prstGeom prst="rect">
             <a:avLst/>
@@ -4842,7 +5060,7 @@
         <p:spPr>
           <a:xfrm>
             <a:off x="838504" y="1627632"/>
-            <a:ext cx="5097780" cy="2144725"/>
+            <a:ext cx="5097780" cy="4060850"/>
           </a:xfrm>
           <a:prstGeom prst="rect">
             <a:avLst/>
@@ -5117,7 +5335,7 @@
         <p:spPr>
           <a:xfrm>
             <a:off x="6256324" y="1627632"/>
-            <a:ext cx="5097780" cy="2144725"/>
+            <a:ext cx="5097780" cy="4060850"/>
           </a:xfrm>
           <a:prstGeom prst="rect">
             <a:avLst/>
@@ -5391,14 +5609,14 @@
         </p:nvSpPr>
         <p:spPr>
           <a:xfrm>
-            <a:off x="838504" y="3823157"/>
-            <a:ext cx="10515600" cy="12700"/>
+            <a:off x="838504" y="5779922"/>
+            <a:ext cx="10515600" cy="502920"/>
           </a:xfrm>
           <a:prstGeom prst="rect">
             <a:avLst/>
           </a:prstGeom>
           <a:solidFill>
-            <a:srgbClr val="CCCCCC"/>
+            <a:srgbClr val="1D3461"/>
           </a:solidFill>
           <a:ln>
             <a:noFill/>
@@ -5435,13 +5653,14 @@
         </p:nvSpPr>
         <p:spPr>
           <a:xfrm>
-            <a:off x="838504" y="3924757"/>
-            <a:ext cx="10515600" cy="2339797"/>
+            <a:off x="1021384" y="5779922"/>
+            <a:ext cx="10149840" cy="502920"/>
           </a:xfrm>
           <a:prstGeom prst="rect">
             <a:avLst/>
           </a:prstGeom>
           <a:noFill/>
+          <a:effectLst/>
         </p:spPr>
         <p:txBody>
           <a:bodyPr wrap="square">
@@ -5449,36 +5668,20 @@
           </a:bodyPr>
           <a:lstStyle/>
           <a:p>
-            <a:pPr>
-              <a:spcBef>
-                <a:spcPts val="600"/>
-              </a:spcBef>
-              <a:spcAft>
-                <a:spcPts val="200"/>
-              </a:spcAft>
-            </a:pPr>
-            <a:r>
-              <a:rPr sz="1600" b="0" i="0">
-                <a:solidFill>
-                  <a:srgbClr val="0066CD"/>
-                </a:solidFill>
-                <a:latin typeface="Meiryo UI"/>
-              </a:rPr>
-              <a:t>● </a:t>
-            </a:r>
-            <a:r>
-              <a:rPr sz="1600" b="1" i="0">
-                <a:solidFill>
-                  <a:srgbClr val="1A1A1A"/>
+            <a:pPr algn="ctr"/>
+            <a:r>
+              <a:rPr sz="1400" b="1" i="0">
+                <a:solidFill>
+                  <a:srgbClr val="FFFFFF"/>
                 </a:solidFill>
                 <a:latin typeface="Meiryo UI"/>
               </a:rPr>
               <a:t>第一歩：</a:t>
             </a:r>
             <a:r>
-              <a:rPr sz="1600" b="0" i="0">
-                <a:solidFill>
-                  <a:srgbClr val="1A1A1A"/>
+              <a:rPr sz="1400" b="0" i="0">
+                <a:solidFill>
+                  <a:srgbClr val="FFFFFF"/>
                 </a:solidFill>
                 <a:latin typeface="Meiryo UI"/>
               </a:rPr>

</xml_diff>

<commit_message>
Update slides_p10_p12.pptx with enriched content
https://claude.ai/code/session_0131QRdg3FhyRqD7kn6YfEQ8
</commit_message>
<xml_diff>
--- a/slides_p10_p12.pptx
+++ b/slides_p10_p12.pptx
@@ -3241,653 +3241,325 @@
                 </a:solidFill>
                 <a:latin typeface="Meiryo UI"/>
               </a:rPr>
-              <a:t>貴社の成長戦略は「No.1 Backoffice AI Company」の実現。「SaaS価値向上」「AIプロダクト」「M&amp;A」を3本柱とし、FY28で売上高900億円を目指す。</a:t>
-            </a:r>
-          </a:p>
-        </p:txBody>
-      </p:sp>
-      <p:sp>
-        <p:nvSpPr>
-          <p:cNvPr id="6" name="Rectangle 5"/>
-          <p:cNvSpPr/>
+              <a:t>貴社の成長戦略は「No.1 Backoffice AI Company」の実現。「SaaS価値向上」「AIプロダクト」「M&amp;A」を3本柱とし、FY28で売上高900億円（現503億の約1.8倍）を目指す。</a:t>
+            </a:r>
+          </a:p>
+        </p:txBody>
+      </p:sp>
+      <p:graphicFrame>
+        <p:nvGraphicFramePr>
+          <p:cNvPr id="6" name="Table 5"/>
+          <p:cNvGraphicFramePr>
+            <a:graphicFrameLocks noGrp="1"/>
+          </p:cNvGraphicFramePr>
           <p:nvPr/>
-        </p:nvSpPr>
-        <p:spPr>
-          <a:xfrm>
-            <a:off x="838504" y="1280160"/>
-            <a:ext cx="3352800" cy="4408322"/>
-          </a:xfrm>
-          <a:prstGeom prst="rect">
-            <a:avLst/>
-          </a:prstGeom>
-          <a:solidFill>
-            <a:srgbClr val="F5F5F5"/>
-          </a:solidFill>
-          <a:ln>
-            <a:noFill/>
-          </a:ln>
-          <a:effectLst/>
-        </p:spPr>
-        <p:style>
-          <a:lnRef idx="1">
-            <a:schemeClr val="accent1"/>
-          </a:lnRef>
-          <a:fillRef idx="3">
-            <a:schemeClr val="accent1"/>
-          </a:fillRef>
-          <a:effectRef idx="2">
-            <a:schemeClr val="accent1"/>
-          </a:effectRef>
-          <a:fontRef idx="minor">
-            <a:schemeClr val="lt1"/>
-          </a:fontRef>
-        </p:style>
-        <p:txBody>
-          <a:bodyPr rtlCol="0" anchor="ctr"/>
-          <a:lstStyle/>
-          <a:p>
-            <a:pPr algn="ctr"/>
-          </a:p>
-        </p:txBody>
-      </p:sp>
+        </p:nvGraphicFramePr>
+        <p:xfrm>
+          <a:off x="838504" y="1280160"/>
+          <a:ext cx="10515600" cy="3657600"/>
+        </p:xfrm>
+        <a:graphic>
+          <a:graphicData uri="http://schemas.openxmlformats.org/drawingml/2006/table">
+            <a:tbl>
+              <a:tblPr firstRow="1" bandRow="1">
+                <a:tableStyleId>{5C22544A-7EE6-4342-B048-85BDC9FD1C3A}</a:tableStyleId>
+              </a:tblPr>
+              <a:tblGrid>
+                <a:gridCol w="3505200"/>
+                <a:gridCol w="3505200"/>
+                <a:gridCol w="3505200"/>
+              </a:tblGrid>
+              <a:tr h="365760">
+                <a:tc>
+                  <a:txBody>
+                    <a:bodyPr wrap="square"/>
+                    <a:lstStyle/>
+                    <a:p>
+                      <a:pPr algn="ctr"/>
+                      <a:r>
+                        <a:rPr sz="1400" b="1" i="0">
+                          <a:solidFill>
+                            <a:srgbClr val="FFFFFF"/>
+                          </a:solidFill>
+                          <a:latin typeface="Meiryo UI"/>
+                        </a:rPr>
+                        <a:t>成長戦略</a:t>
+                      </a:r>
+                    </a:p>
+                  </a:txBody>
+                  <a:tcPr>
+                    <a:solidFill>
+                      <a:srgbClr val="1D3461"/>
+                    </a:solidFill>
+                  </a:tcPr>
+                </a:tc>
+                <a:tc>
+                  <a:txBody>
+                    <a:bodyPr wrap="square"/>
+                    <a:lstStyle/>
+                    <a:p>
+                      <a:pPr algn="ctr"/>
+                      <a:r>
+                        <a:rPr sz="1400" b="1" i="0">
+                          <a:solidFill>
+                            <a:srgbClr val="FFFFFF"/>
+                          </a:solidFill>
+                          <a:latin typeface="Meiryo UI"/>
+                        </a:rPr>
+                        <a:t>具体内容</a:t>
+                      </a:r>
+                    </a:p>
+                  </a:txBody>
+                  <a:tcPr>
+                    <a:solidFill>
+                      <a:srgbClr val="1D3461"/>
+                    </a:solidFill>
+                  </a:tcPr>
+                </a:tc>
+                <a:tc>
+                  <a:txBody>
+                    <a:bodyPr wrap="square"/>
+                    <a:lstStyle/>
+                    <a:p>
+                      <a:pPr algn="ctr"/>
+                      <a:r>
+                        <a:rPr sz="1400" b="1" i="0">
+                          <a:solidFill>
+                            <a:srgbClr val="FFFFFF"/>
+                          </a:solidFill>
+                          <a:latin typeface="Meiryo UI"/>
+                        </a:rPr>
+                        <a:t>目指す姿</a:t>
+                      </a:r>
+                    </a:p>
+                  </a:txBody>
+                  <a:tcPr>
+                    <a:solidFill>
+                      <a:srgbClr val="1D3461"/>
+                    </a:solidFill>
+                  </a:tcPr>
+                </a:tc>
+              </a:tr>
+              <a:tr h="1097280">
+                <a:tc>
+                  <a:txBody>
+                    <a:bodyPr wrap="square"/>
+                    <a:lstStyle/>
+                    <a:p>
+                      <a:pPr algn="l"/>
+                      <a:r>
+                        <a:rPr sz="1400" b="0" i="0">
+                          <a:solidFill>
+                            <a:srgbClr val="1A1A1A"/>
+                          </a:solidFill>
+                          <a:latin typeface="Meiryo UI"/>
+                        </a:rPr>
+                        <a:t>バックオフィスSaaSの価値向上</a:t>
+                      </a:r>
+                    </a:p>
+                  </a:txBody>
+                  <a:tcPr>
+                    <a:solidFill>
+                      <a:srgbClr val="F5F7FA"/>
+                    </a:solidFill>
+                  </a:tcPr>
+                </a:tc>
+                <a:tc>
+                  <a:txBody>
+                    <a:bodyPr wrap="square"/>
+                    <a:lstStyle/>
+                    <a:p>
+                      <a:pPr algn="l"/>
+                      <a:r>
+                        <a:rPr sz="1400" b="0" i="0">
+                          <a:solidFill>
+                            <a:srgbClr val="1A1A1A"/>
+                          </a:solidFill>
+                          <a:latin typeface="Meiryo UI"/>
+                        </a:rPr>
+                        <a:t>60超のプロダクトで会計・人事・法務を網羅。顧客基盤の拡大とARPA向上を推進。豊富なサービスラインナップと業務ロジックを強みに</a:t>
+                      </a:r>
+                    </a:p>
+                  </a:txBody>
+                  <a:tcPr>
+                    <a:solidFill>
+                      <a:srgbClr val="F5F7FA"/>
+                    </a:solidFill>
+                  </a:tcPr>
+                </a:tc>
+                <a:tc>
+                  <a:txBody>
+                    <a:bodyPr wrap="square"/>
+                    <a:lstStyle/>
+                    <a:p>
+                      <a:pPr algn="l"/>
+                      <a:r>
+                        <a:rPr sz="1400" b="0" i="0">
+                          <a:solidFill>
+                            <a:srgbClr val="1A1A1A"/>
+                          </a:solidFill>
+                          <a:latin typeface="Meiryo UI"/>
+                        </a:rPr>
+                        <a:t>顧客基盤の拡大とARPAの向上</a:t>
+                      </a:r>
+                    </a:p>
+                  </a:txBody>
+                  <a:tcPr>
+                    <a:solidFill>
+                      <a:srgbClr val="F5F7FA"/>
+                    </a:solidFill>
+                  </a:tcPr>
+                </a:tc>
+              </a:tr>
+              <a:tr h="1097280">
+                <a:tc>
+                  <a:txBody>
+                    <a:bodyPr wrap="square"/>
+                    <a:lstStyle/>
+                    <a:p>
+                      <a:pPr algn="l"/>
+                      <a:r>
+                        <a:rPr sz="1400" b="0" i="0">
+                          <a:solidFill>
+                            <a:srgbClr val="1A1A1A"/>
+                          </a:solidFill>
+                          <a:latin typeface="Meiryo UI"/>
+                        </a:rPr>
+                        <a:t>AIプロダクトの開発・提供</a:t>
+                      </a:r>
+                    </a:p>
+                  </a:txBody>
+                  <a:tcPr>
+                    <a:solidFill>
+                      <a:srgbClr val="FFFFFF"/>
+                    </a:solidFill>
+                  </a:tcPr>
+                </a:tc>
+                <a:tc>
+                  <a:txBody>
+                    <a:bodyPr wrap="square"/>
+                    <a:lstStyle/>
+                    <a:p>
+                      <a:pPr algn="l"/>
+                      <a:r>
+                        <a:rPr sz="1400" b="0" i="0">
+                          <a:solidFill>
+                            <a:srgbClr val="1A1A1A"/>
+                          </a:solidFill>
+                          <a:latin typeface="Meiryo UI"/>
+                        </a:rPr>
+                        <a:t>AIエージェント／AIネイティブプロダクト／AI×BPOサービスの展開。業務ロジックを活用し自律的に処理。デジタルツール市場からデジタルワーカー市場へ</a:t>
+                      </a:r>
+                    </a:p>
+                  </a:txBody>
+                  <a:tcPr>
+                    <a:solidFill>
+                      <a:srgbClr val="FFFFFF"/>
+                    </a:solidFill>
+                  </a:tcPr>
+                </a:tc>
+                <a:tc>
+                  <a:txBody>
+                    <a:bodyPr wrap="square"/>
+                    <a:lstStyle/>
+                    <a:p>
+                      <a:pPr algn="l"/>
+                      <a:r>
+                        <a:rPr sz="1400" b="0" i="0">
+                          <a:solidFill>
+                            <a:srgbClr val="1A1A1A"/>
+                          </a:solidFill>
+                          <a:latin typeface="Meiryo UI"/>
+                        </a:rPr>
+                        <a:t>デジタルワーカー市場（14.1兆円）へのTAM拡大</a:t>
+                      </a:r>
+                    </a:p>
+                  </a:txBody>
+                  <a:tcPr>
+                    <a:solidFill>
+                      <a:srgbClr val="FFFFFF"/>
+                    </a:solidFill>
+                  </a:tcPr>
+                </a:tc>
+              </a:tr>
+              <a:tr h="1097280">
+                <a:tc>
+                  <a:txBody>
+                    <a:bodyPr wrap="square"/>
+                    <a:lstStyle/>
+                    <a:p>
+                      <a:pPr algn="l"/>
+                      <a:r>
+                        <a:rPr sz="1400" b="0" i="0">
+                          <a:solidFill>
+                            <a:srgbClr val="1A1A1A"/>
+                          </a:solidFill>
+                          <a:latin typeface="Meiryo UI"/>
+                        </a:rPr>
+                        <a:t>M&amp;A戦略の遂行</a:t>
+                      </a:r>
+                    </a:p>
+                  </a:txBody>
+                  <a:tcPr>
+                    <a:solidFill>
+                      <a:srgbClr val="F5F7FA"/>
+                    </a:solidFill>
+                  </a:tcPr>
+                </a:tc>
+                <a:tc>
+                  <a:txBody>
+                    <a:bodyPr wrap="square"/>
+                    <a:lstStyle/>
+                    <a:p>
+                      <a:pPr algn="l"/>
+                      <a:r>
+                        <a:rPr sz="1400" b="0" i="0">
+                          <a:solidFill>
+                            <a:srgbClr val="1A1A1A"/>
+                          </a:solidFill>
+                          <a:latin typeface="Meiryo UI"/>
+                        </a:rPr>
+                        <a:t>経営管理領域を全方位でカバーするためサービスの幅を拡大。アウトルックコンサルティング社等のグループジョイン。SaaS×Fintechの融合</a:t>
+                      </a:r>
+                    </a:p>
+                  </a:txBody>
+                  <a:tcPr>
+                    <a:solidFill>
+                      <a:srgbClr val="F5F7FA"/>
+                    </a:solidFill>
+                  </a:tcPr>
+                </a:tc>
+                <a:tc>
+                  <a:txBody>
+                    <a:bodyPr wrap="square"/>
+                    <a:lstStyle/>
+                    <a:p>
+                      <a:pPr algn="l"/>
+                      <a:r>
+                        <a:rPr sz="1400" b="0" i="0">
+                          <a:solidFill>
+                            <a:srgbClr val="1A1A1A"/>
+                          </a:solidFill>
+                          <a:latin typeface="Meiryo UI"/>
+                        </a:rPr>
+                        <a:t>サービス拡充による顧客基盤拡大</a:t>
+                      </a:r>
+                    </a:p>
+                  </a:txBody>
+                  <a:tcPr>
+                    <a:solidFill>
+                      <a:srgbClr val="F5F7FA"/>
+                    </a:solidFill>
+                  </a:tcPr>
+                </a:tc>
+              </a:tr>
+            </a:tbl>
+          </a:graphicData>
+        </a:graphic>
+      </p:graphicFrame>
       <p:sp>
         <p:nvSpPr>
           <p:cNvPr id="7" name="Rectangle 6"/>
-          <p:cNvSpPr/>
-          <p:nvPr/>
-        </p:nvSpPr>
-        <p:spPr>
-          <a:xfrm>
-            <a:off x="838504" y="1280160"/>
-            <a:ext cx="3352800" cy="101600"/>
-          </a:xfrm>
-          <a:prstGeom prst="rect">
-            <a:avLst/>
-          </a:prstGeom>
-          <a:solidFill>
-            <a:srgbClr val="0066CD"/>
-          </a:solidFill>
-          <a:ln>
-            <a:noFill/>
-          </a:ln>
-          <a:effectLst/>
-        </p:spPr>
-        <p:style>
-          <a:lnRef idx="1">
-            <a:schemeClr val="accent1"/>
-          </a:lnRef>
-          <a:fillRef idx="3">
-            <a:schemeClr val="accent1"/>
-          </a:fillRef>
-          <a:effectRef idx="2">
-            <a:schemeClr val="accent1"/>
-          </a:effectRef>
-          <a:fontRef idx="minor">
-            <a:schemeClr val="lt1"/>
-          </a:fontRef>
-        </p:style>
-        <p:txBody>
-          <a:bodyPr rtlCol="0" anchor="ctr"/>
-          <a:lstStyle/>
-          <a:p>
-            <a:pPr algn="ctr"/>
-          </a:p>
-        </p:txBody>
-      </p:sp>
-      <p:sp>
-        <p:nvSpPr>
-          <p:cNvPr id="8" name="Oval 7"/>
-          <p:cNvSpPr/>
-          <p:nvPr/>
-        </p:nvSpPr>
-        <p:spPr>
-          <a:xfrm>
-            <a:off x="2286304" y="1518920"/>
-            <a:ext cx="457200" cy="457200"/>
-          </a:xfrm>
-          <a:prstGeom prst="ellipse">
-            <a:avLst/>
-          </a:prstGeom>
-          <a:solidFill>
-            <a:srgbClr val="0066CD"/>
-          </a:solidFill>
-          <a:ln>
-            <a:noFill/>
-          </a:ln>
-          <a:effectLst/>
-        </p:spPr>
-        <p:style>
-          <a:lnRef idx="1">
-            <a:schemeClr val="accent1"/>
-          </a:lnRef>
-          <a:fillRef idx="3">
-            <a:schemeClr val="accent1"/>
-          </a:fillRef>
-          <a:effectRef idx="2">
-            <a:schemeClr val="accent1"/>
-          </a:effectRef>
-          <a:fontRef idx="minor">
-            <a:schemeClr val="lt1"/>
-          </a:fontRef>
-        </p:style>
-        <p:txBody>
-          <a:bodyPr rtlCol="0" anchor="ctr" wrap="none"/>
-          <a:lstStyle/>
-          <a:p>
-            <a:pPr algn="ctr"/>
-            <a:r>
-              <a:rPr sz="1000" b="1" i="0">
-                <a:solidFill>
-                  <a:srgbClr val="FFFFFF"/>
-                </a:solidFill>
-                <a:latin typeface="Meiryo UI"/>
-              </a:rPr>
-              <a:t>SaaS</a:t>
-            </a:r>
-          </a:p>
-        </p:txBody>
-      </p:sp>
-      <p:sp>
-        <p:nvSpPr>
-          <p:cNvPr id="9" name="TextBox 8"/>
-          <p:cNvSpPr txBox="1"/>
-          <p:nvPr/>
-        </p:nvSpPr>
-        <p:spPr>
-          <a:xfrm>
-            <a:off x="948232" y="2067560"/>
-            <a:ext cx="3133344" cy="457200"/>
-          </a:xfrm>
-          <a:prstGeom prst="rect">
-            <a:avLst/>
-          </a:prstGeom>
-          <a:noFill/>
-          <a:effectLst/>
-        </p:spPr>
-        <p:txBody>
-          <a:bodyPr wrap="square">
-            <a:spAutoFit/>
-          </a:bodyPr>
-          <a:lstStyle/>
-          <a:p>
-            <a:pPr algn="ctr"/>
-            <a:r>
-              <a:rPr sz="1400" b="1" i="0">
-                <a:solidFill>
-                  <a:srgbClr val="1A1A1A"/>
-                </a:solidFill>
-                <a:latin typeface="Meiryo UI"/>
-              </a:rPr>
-              <a:t>バックオフィスSaaSの価値向上</a:t>
-            </a:r>
-          </a:p>
-        </p:txBody>
-      </p:sp>
-      <p:sp>
-        <p:nvSpPr>
-          <p:cNvPr id="10" name="TextBox 9"/>
-          <p:cNvSpPr txBox="1"/>
-          <p:nvPr/>
-        </p:nvSpPr>
-        <p:spPr>
-          <a:xfrm>
-            <a:off x="948232" y="2524760"/>
-            <a:ext cx="3133344" cy="3163722"/>
-          </a:xfrm>
-          <a:prstGeom prst="rect">
-            <a:avLst/>
-          </a:prstGeom>
-          <a:noFill/>
-          <a:effectLst/>
-        </p:spPr>
-        <p:txBody>
-          <a:bodyPr wrap="square">
-            <a:spAutoFit/>
-          </a:bodyPr>
-          <a:lstStyle/>
-          <a:p>
-            <a:pPr algn="ctr"/>
-            <a:r>
-              <a:rPr sz="1200" b="0" i="0">
-                <a:solidFill>
-                  <a:srgbClr val="888888"/>
-                </a:solidFill>
-                <a:latin typeface="Meiryo UI"/>
-              </a:rPr>
-              <a:t>60超のプロダクトで会計・人事・法務を網羅。顧客基盤の拡大とARPA向上</a:t>
-            </a:r>
-          </a:p>
-        </p:txBody>
-      </p:sp>
-      <p:sp>
-        <p:nvSpPr>
-          <p:cNvPr id="11" name="Rectangle 10"/>
-          <p:cNvSpPr/>
-          <p:nvPr/>
-        </p:nvSpPr>
-        <p:spPr>
-          <a:xfrm>
-            <a:off x="4419904" y="1280160"/>
-            <a:ext cx="3352800" cy="4408322"/>
-          </a:xfrm>
-          <a:prstGeom prst="rect">
-            <a:avLst/>
-          </a:prstGeom>
-          <a:solidFill>
-            <a:srgbClr val="F5F5F5"/>
-          </a:solidFill>
-          <a:ln>
-            <a:noFill/>
-          </a:ln>
-          <a:effectLst/>
-        </p:spPr>
-        <p:style>
-          <a:lnRef idx="1">
-            <a:schemeClr val="accent1"/>
-          </a:lnRef>
-          <a:fillRef idx="3">
-            <a:schemeClr val="accent1"/>
-          </a:fillRef>
-          <a:effectRef idx="2">
-            <a:schemeClr val="accent1"/>
-          </a:effectRef>
-          <a:fontRef idx="minor">
-            <a:schemeClr val="lt1"/>
-          </a:fontRef>
-        </p:style>
-        <p:txBody>
-          <a:bodyPr rtlCol="0" anchor="ctr"/>
-          <a:lstStyle/>
-          <a:p>
-            <a:pPr algn="ctr"/>
-          </a:p>
-        </p:txBody>
-      </p:sp>
-      <p:sp>
-        <p:nvSpPr>
-          <p:cNvPr id="12" name="Rectangle 11"/>
-          <p:cNvSpPr/>
-          <p:nvPr/>
-        </p:nvSpPr>
-        <p:spPr>
-          <a:xfrm>
-            <a:off x="4419904" y="1280160"/>
-            <a:ext cx="3352800" cy="101600"/>
-          </a:xfrm>
-          <a:prstGeom prst="rect">
-            <a:avLst/>
-          </a:prstGeom>
-          <a:solidFill>
-            <a:srgbClr val="E07F30"/>
-          </a:solidFill>
-          <a:ln>
-            <a:noFill/>
-          </a:ln>
-          <a:effectLst/>
-        </p:spPr>
-        <p:style>
-          <a:lnRef idx="1">
-            <a:schemeClr val="accent1"/>
-          </a:lnRef>
-          <a:fillRef idx="3">
-            <a:schemeClr val="accent1"/>
-          </a:fillRef>
-          <a:effectRef idx="2">
-            <a:schemeClr val="accent1"/>
-          </a:effectRef>
-          <a:fontRef idx="minor">
-            <a:schemeClr val="lt1"/>
-          </a:fontRef>
-        </p:style>
-        <p:txBody>
-          <a:bodyPr rtlCol="0" anchor="ctr"/>
-          <a:lstStyle/>
-          <a:p>
-            <a:pPr algn="ctr"/>
-          </a:p>
-        </p:txBody>
-      </p:sp>
-      <p:sp>
-        <p:nvSpPr>
-          <p:cNvPr id="13" name="Oval 12"/>
-          <p:cNvSpPr/>
-          <p:nvPr/>
-        </p:nvSpPr>
-        <p:spPr>
-          <a:xfrm>
-            <a:off x="5867704" y="1518920"/>
-            <a:ext cx="457200" cy="457200"/>
-          </a:xfrm>
-          <a:prstGeom prst="ellipse">
-            <a:avLst/>
-          </a:prstGeom>
-          <a:solidFill>
-            <a:srgbClr val="E07F30"/>
-          </a:solidFill>
-          <a:ln>
-            <a:noFill/>
-          </a:ln>
-          <a:effectLst/>
-        </p:spPr>
-        <p:style>
-          <a:lnRef idx="1">
-            <a:schemeClr val="accent1"/>
-          </a:lnRef>
-          <a:fillRef idx="3">
-            <a:schemeClr val="accent1"/>
-          </a:fillRef>
-          <a:effectRef idx="2">
-            <a:schemeClr val="accent1"/>
-          </a:effectRef>
-          <a:fontRef idx="minor">
-            <a:schemeClr val="lt1"/>
-          </a:fontRef>
-        </p:style>
-        <p:txBody>
-          <a:bodyPr rtlCol="0" anchor="ctr" wrap="none"/>
-          <a:lstStyle/>
-          <a:p>
-            <a:pPr algn="ctr"/>
-            <a:r>
-              <a:rPr sz="1000" b="1" i="0">
-                <a:solidFill>
-                  <a:srgbClr val="FFFFFF"/>
-                </a:solidFill>
-                <a:latin typeface="Meiryo UI"/>
-              </a:rPr>
-              <a:t>AI</a:t>
-            </a:r>
-          </a:p>
-        </p:txBody>
-      </p:sp>
-      <p:sp>
-        <p:nvSpPr>
-          <p:cNvPr id="14" name="TextBox 13"/>
-          <p:cNvSpPr txBox="1"/>
-          <p:nvPr/>
-        </p:nvSpPr>
-        <p:spPr>
-          <a:xfrm>
-            <a:off x="4529632" y="2067560"/>
-            <a:ext cx="3133344" cy="457200"/>
-          </a:xfrm>
-          <a:prstGeom prst="rect">
-            <a:avLst/>
-          </a:prstGeom>
-          <a:noFill/>
-          <a:effectLst/>
-        </p:spPr>
-        <p:txBody>
-          <a:bodyPr wrap="square">
-            <a:spAutoFit/>
-          </a:bodyPr>
-          <a:lstStyle/>
-          <a:p>
-            <a:pPr algn="ctr"/>
-            <a:r>
-              <a:rPr sz="1400" b="1" i="0">
-                <a:solidFill>
-                  <a:srgbClr val="1A1A1A"/>
-                </a:solidFill>
-                <a:latin typeface="Meiryo UI"/>
-              </a:rPr>
-              <a:t>AIプロダクトの開発・提供</a:t>
-            </a:r>
-          </a:p>
-        </p:txBody>
-      </p:sp>
-      <p:sp>
-        <p:nvSpPr>
-          <p:cNvPr id="15" name="TextBox 14"/>
-          <p:cNvSpPr txBox="1"/>
-          <p:nvPr/>
-        </p:nvSpPr>
-        <p:spPr>
-          <a:xfrm>
-            <a:off x="4529632" y="2524760"/>
-            <a:ext cx="3133344" cy="3163722"/>
-          </a:xfrm>
-          <a:prstGeom prst="rect">
-            <a:avLst/>
-          </a:prstGeom>
-          <a:noFill/>
-          <a:effectLst/>
-        </p:spPr>
-        <p:txBody>
-          <a:bodyPr wrap="square">
-            <a:spAutoFit/>
-          </a:bodyPr>
-          <a:lstStyle/>
-          <a:p>
-            <a:pPr algn="ctr"/>
-            <a:r>
-              <a:rPr sz="1200" b="0" i="0">
-                <a:solidFill>
-                  <a:srgbClr val="888888"/>
-                </a:solidFill>
-                <a:latin typeface="Meiryo UI"/>
-              </a:rPr>
-              <a:t>AIエージェント・AIネイティブプロダクト・AI×BPOで業務を自律処理</a:t>
-            </a:r>
-          </a:p>
-        </p:txBody>
-      </p:sp>
-      <p:sp>
-        <p:nvSpPr>
-          <p:cNvPr id="16" name="Rectangle 15"/>
-          <p:cNvSpPr/>
-          <p:nvPr/>
-        </p:nvSpPr>
-        <p:spPr>
-          <a:xfrm>
-            <a:off x="8001304" y="1280160"/>
-            <a:ext cx="3352800" cy="4408322"/>
-          </a:xfrm>
-          <a:prstGeom prst="rect">
-            <a:avLst/>
-          </a:prstGeom>
-          <a:solidFill>
-            <a:srgbClr val="F5F5F5"/>
-          </a:solidFill>
-          <a:ln>
-            <a:noFill/>
-          </a:ln>
-          <a:effectLst/>
-        </p:spPr>
-        <p:style>
-          <a:lnRef idx="1">
-            <a:schemeClr val="accent1"/>
-          </a:lnRef>
-          <a:fillRef idx="3">
-            <a:schemeClr val="accent1"/>
-          </a:fillRef>
-          <a:effectRef idx="2">
-            <a:schemeClr val="accent1"/>
-          </a:effectRef>
-          <a:fontRef idx="minor">
-            <a:schemeClr val="lt1"/>
-          </a:fontRef>
-        </p:style>
-        <p:txBody>
-          <a:bodyPr rtlCol="0" anchor="ctr"/>
-          <a:lstStyle/>
-          <a:p>
-            <a:pPr algn="ctr"/>
-          </a:p>
-        </p:txBody>
-      </p:sp>
-      <p:sp>
-        <p:nvSpPr>
-          <p:cNvPr id="17" name="Rectangle 16"/>
-          <p:cNvSpPr/>
-          <p:nvPr/>
-        </p:nvSpPr>
-        <p:spPr>
-          <a:xfrm>
-            <a:off x="8001304" y="1280160"/>
-            <a:ext cx="3352800" cy="101600"/>
-          </a:xfrm>
-          <a:prstGeom prst="rect">
-            <a:avLst/>
-          </a:prstGeom>
-          <a:solidFill>
-            <a:srgbClr val="7B61C5"/>
-          </a:solidFill>
-          <a:ln>
-            <a:noFill/>
-          </a:ln>
-          <a:effectLst/>
-        </p:spPr>
-        <p:style>
-          <a:lnRef idx="1">
-            <a:schemeClr val="accent1"/>
-          </a:lnRef>
-          <a:fillRef idx="3">
-            <a:schemeClr val="accent1"/>
-          </a:fillRef>
-          <a:effectRef idx="2">
-            <a:schemeClr val="accent1"/>
-          </a:effectRef>
-          <a:fontRef idx="minor">
-            <a:schemeClr val="lt1"/>
-          </a:fontRef>
-        </p:style>
-        <p:txBody>
-          <a:bodyPr rtlCol="0" anchor="ctr"/>
-          <a:lstStyle/>
-          <a:p>
-            <a:pPr algn="ctr"/>
-          </a:p>
-        </p:txBody>
-      </p:sp>
-      <p:sp>
-        <p:nvSpPr>
-          <p:cNvPr id="18" name="Oval 17"/>
-          <p:cNvSpPr/>
-          <p:nvPr/>
-        </p:nvSpPr>
-        <p:spPr>
-          <a:xfrm>
-            <a:off x="9449104" y="1518920"/>
-            <a:ext cx="457200" cy="457200"/>
-          </a:xfrm>
-          <a:prstGeom prst="ellipse">
-            <a:avLst/>
-          </a:prstGeom>
-          <a:solidFill>
-            <a:srgbClr val="7B61C5"/>
-          </a:solidFill>
-          <a:ln>
-            <a:noFill/>
-          </a:ln>
-          <a:effectLst/>
-        </p:spPr>
-        <p:style>
-          <a:lnRef idx="1">
-            <a:schemeClr val="accent1"/>
-          </a:lnRef>
-          <a:fillRef idx="3">
-            <a:schemeClr val="accent1"/>
-          </a:fillRef>
-          <a:effectRef idx="2">
-            <a:schemeClr val="accent1"/>
-          </a:effectRef>
-          <a:fontRef idx="minor">
-            <a:schemeClr val="lt1"/>
-          </a:fontRef>
-        </p:style>
-        <p:txBody>
-          <a:bodyPr rtlCol="0" anchor="ctr" wrap="none"/>
-          <a:lstStyle/>
-          <a:p>
-            <a:pPr algn="ctr"/>
-            <a:r>
-              <a:rPr sz="1000" b="1" i="0">
-                <a:solidFill>
-                  <a:srgbClr val="FFFFFF"/>
-                </a:solidFill>
-                <a:latin typeface="Meiryo UI"/>
-              </a:rPr>
-              <a:t>M&amp;A</a:t>
-            </a:r>
-          </a:p>
-        </p:txBody>
-      </p:sp>
-      <p:sp>
-        <p:nvSpPr>
-          <p:cNvPr id="19" name="TextBox 18"/>
-          <p:cNvSpPr txBox="1"/>
-          <p:nvPr/>
-        </p:nvSpPr>
-        <p:spPr>
-          <a:xfrm>
-            <a:off x="8111032" y="2067560"/>
-            <a:ext cx="3133344" cy="457200"/>
-          </a:xfrm>
-          <a:prstGeom prst="rect">
-            <a:avLst/>
-          </a:prstGeom>
-          <a:noFill/>
-          <a:effectLst/>
-        </p:spPr>
-        <p:txBody>
-          <a:bodyPr wrap="square">
-            <a:spAutoFit/>
-          </a:bodyPr>
-          <a:lstStyle/>
-          <a:p>
-            <a:pPr algn="ctr"/>
-            <a:r>
-              <a:rPr sz="1400" b="1" i="0">
-                <a:solidFill>
-                  <a:srgbClr val="1A1A1A"/>
-                </a:solidFill>
-                <a:latin typeface="Meiryo UI"/>
-              </a:rPr>
-              <a:t>M&amp;A戦略の遂行</a:t>
-            </a:r>
-          </a:p>
-        </p:txBody>
-      </p:sp>
-      <p:sp>
-        <p:nvSpPr>
-          <p:cNvPr id="20" name="TextBox 19"/>
-          <p:cNvSpPr txBox="1"/>
-          <p:nvPr/>
-        </p:nvSpPr>
-        <p:spPr>
-          <a:xfrm>
-            <a:off x="8111032" y="2524760"/>
-            <a:ext cx="3133344" cy="3163722"/>
-          </a:xfrm>
-          <a:prstGeom prst="rect">
-            <a:avLst/>
-          </a:prstGeom>
-          <a:noFill/>
-          <a:effectLst/>
-        </p:spPr>
-        <p:txBody>
-          <a:bodyPr wrap="square">
-            <a:spAutoFit/>
-          </a:bodyPr>
-          <a:lstStyle/>
-          <a:p>
-            <a:pPr algn="ctr"/>
-            <a:r>
-              <a:rPr sz="1200" b="0" i="0">
-                <a:solidFill>
-                  <a:srgbClr val="888888"/>
-                </a:solidFill>
-                <a:latin typeface="Meiryo UI"/>
-              </a:rPr>
-              <a:t>サービスラインナップ拡充。経営管理領域を全方位でカバーする体制を構築</a:t>
-            </a:r>
-          </a:p>
-        </p:txBody>
-      </p:sp>
-      <p:sp>
-        <p:nvSpPr>
-          <p:cNvPr id="21" name="Rectangle 20"/>
           <p:cNvSpPr/>
           <p:nvPr/>
         </p:nvSpPr>
@@ -3931,7 +3603,7 @@
       </p:sp>
       <p:sp>
         <p:nvSpPr>
-          <p:cNvPr id="22" name="TextBox 21"/>
+          <p:cNvPr id="8" name="TextBox 7"/>
           <p:cNvSpPr txBox="1"/>
           <p:nvPr/>
         </p:nvSpPr>
@@ -3960,7 +3632,7 @@
                 </a:solidFill>
                 <a:latin typeface="Meiryo UI"/>
               </a:rPr>
-              <a:t>TAMの5倍拡大：</a:t>
+              <a:t>FY28 中長期財務ターゲット：</a:t>
             </a:r>
             <a:r>
               <a:rPr sz="1400" b="0" i="0">
@@ -3969,14 +3641,14 @@
                 </a:solidFill>
                 <a:latin typeface="Meiryo UI"/>
               </a:rPr>
-              <a:t> デジタルツール市場（2.8兆円）→ デジタルワーカー市場（14.1兆円）へ　｜　FY28目標：売上900億円以上 / EBITDA270億円以上 / 事業CF180億円以上</a:t>
+              <a:t> 売上高900億円以上 / EBITDA270億円以上 / 事業CF180億円以上　｜　TAMの5倍拡大：デジタルツール市場（2.8兆円）→ デジタルワーカー市場（14.1兆円）</a:t>
             </a:r>
           </a:p>
         </p:txBody>
       </p:sp>
       <p:pic>
         <p:nvPicPr>
-          <p:cNvPr id="23" name="Picture 22" descr="logo.png"/>
+          <p:cNvPr id="9" name="Picture 8" descr="logo.png"/>
           <p:cNvPicPr>
             <a:picLocks noChangeAspect="1"/>
           </p:cNvPicPr>
@@ -4000,7 +3672,7 @@
       </p:pic>
       <p:sp>
         <p:nvSpPr>
-          <p:cNvPr id="24" name="Rectangle 23"/>
+          <p:cNvPr id="10" name="Rectangle 9"/>
           <p:cNvSpPr/>
           <p:nvPr/>
         </p:nvSpPr>
@@ -4044,7 +3716,7 @@
       </p:sp>
       <p:sp>
         <p:nvSpPr>
-          <p:cNvPr id="25" name="TextBox 24"/>
+          <p:cNvPr id="11" name="TextBox 10"/>
           <p:cNvSpPr txBox="1"/>
           <p:nvPr/>
         </p:nvSpPr>
@@ -4078,7 +3750,7 @@
       </p:sp>
       <p:sp>
         <p:nvSpPr>
-          <p:cNvPr id="26" name="TextBox 25"/>
+          <p:cNvPr id="12" name="TextBox 11"/>
           <p:cNvSpPr txBox="1"/>
           <p:nvPr/>
         </p:nvSpPr>
@@ -4280,7 +3952,7 @@
                 </a:solidFill>
                 <a:latin typeface="Meiryo UI"/>
               </a:rPr>
-              <a:t>お電話でお伺いした内容を整理し、貴社固有の課題仮説を立てさせていただきました。合っている・合っていないも含めて率直にお聞かせいただければと思います。</a:t>
+              <a:t>お電話でお伺いした事実から、貴社固有の課題仮説を整理しました。合っている・合っていないも含めて率直にお聞かせいただければと思います。</a:t>
             </a:r>
           </a:p>
         </p:txBody>
@@ -4304,8 +3976,9 @@
                 <a:tableStyleId>{5C22544A-7EE6-4342-B048-85BDC9FD1C3A}</a:tableStyleId>
               </a:tblPr>
               <a:tblGrid>
-                <a:gridCol w="5257800"/>
-                <a:gridCol w="5257800"/>
+                <a:gridCol w="3505200"/>
+                <a:gridCol w="3505200"/>
+                <a:gridCol w="3505200"/>
               </a:tblGrid>
               <a:tr h="365760">
                 <a:tc>
@@ -4344,7 +4017,30 @@
                           </a:solidFill>
                           <a:latin typeface="Meiryo UI"/>
                         </a:rPr>
-                        <a:t>課題の核心（Insight）</a:t>
+                        <a:t>課題仮説</a:t>
+                      </a:r>
+                    </a:p>
+                  </a:txBody>
+                  <a:tcPr>
+                    <a:solidFill>
+                      <a:srgbClr val="1D3461"/>
+                    </a:solidFill>
+                  </a:tcPr>
+                </a:tc>
+                <a:tc>
+                  <a:txBody>
+                    <a:bodyPr wrap="square"/>
+                    <a:lstStyle/>
+                    <a:p>
+                      <a:pPr algn="ctr"/>
+                      <a:r>
+                        <a:rPr sz="1400" b="1" i="0">
+                          <a:solidFill>
+                            <a:srgbClr val="FFFFFF"/>
+                          </a:solidFill>
+                          <a:latin typeface="Meiryo UI"/>
+                        </a:rPr>
+                        <a:t>なぜ起きているか（マネフォ固有の構造要因）</a:t>
                       </a:r>
                     </a:p>
                   </a:txBody>
@@ -4369,7 +4065,7 @@
                           </a:solidFill>
                           <a:latin typeface="Meiryo UI"/>
                         </a:rPr>
-                        <a:t>受注率に個人間バラつき</a:t>
+                        <a:t>受注率に個人間バラつき。機能売りになりがち。提案の仮説もばらつく</a:t>
                       </a:r>
                     </a:p>
                   </a:txBody>
@@ -4392,7 +4088,7 @@
                           </a:solidFill>
                           <a:latin typeface="Meiryo UI"/>
                         </a:rPr>
-                        <a:t>提案の型がない。</a:t>
+                        <a:t>「課題パターン×プロダクト組み合わせ」の型がない。</a:t>
                       </a:r>
                       <a:r>
                         <a:rPr sz="1400" b="0" i="0">
@@ -4401,7 +4097,30 @@
                           </a:solidFill>
                           <a:latin typeface="Meiryo UI"/>
                         </a:rPr>
-                        <a:t> 60超プロダクトの最適組み合わせは個人知識依存。型なし＝商品知識の差＝受注率の差</a:t>
+                        <a:t> 60超プロダクトの最適組み合わせは個人の商品知識依存。型なし＝商品知識の差＝受注率の差</a:t>
+                      </a:r>
+                    </a:p>
+                  </a:txBody>
+                  <a:tcPr>
+                    <a:solidFill>
+                      <a:srgbClr val="F5F7FA"/>
+                    </a:solidFill>
+                  </a:tcPr>
+                </a:tc>
+                <a:tc>
+                  <a:txBody>
+                    <a:bodyPr wrap="square"/>
+                    <a:lstStyle/>
+                    <a:p>
+                      <a:pPr algn="l"/>
+                      <a:r>
+                        <a:rPr sz="1400" b="0" i="0">
+                          <a:solidFill>
+                            <a:srgbClr val="1A1A1A"/>
+                          </a:solidFill>
+                          <a:latin typeface="Meiryo UI"/>
+                        </a:rPr>
+                        <a:t>会計は業種×規模×フェーズで業務フローが根本的に異なり汎用スクリプトでは対応不可。競合との機能比較→価格勝負に陥り提案の質でしか差がつかない</a:t>
                       </a:r>
                     </a:p>
                   </a:txBody>
@@ -4426,7 +4145,7 @@
                           </a:solidFill>
                           <a:latin typeface="Meiryo UI"/>
                         </a:rPr>
-                        <a:t>中途がワークしない（1人あたり売上低下）</a:t>
+                        <a:t>中途採用を増やしているがワークしない。1人あたり売上が低下</a:t>
                       </a:r>
                     </a:p>
                   </a:txBody>
@@ -4458,7 +4177,30 @@
                           </a:solidFill>
                           <a:latin typeface="Meiryo UI"/>
                         </a:rPr>
-                        <a:t> 会計×60超×SaaS/Fintech/AI三層構造は他SaaSと別次元</a:t>
+                        <a:t> 採用時の評価と実配属後のパフォーマンスにギャップが生じやすい</a:t>
+                      </a:r>
+                    </a:p>
+                  </a:txBody>
+                  <a:tcPr>
+                    <a:solidFill>
+                      <a:srgbClr val="FFFFFF"/>
+                    </a:solidFill>
+                  </a:tcPr>
+                </a:tc>
+                <a:tc>
+                  <a:txBody>
+                    <a:bodyPr wrap="square"/>
+                    <a:lstStyle/>
+                    <a:p>
+                      <a:pPr algn="l"/>
+                      <a:r>
+                        <a:rPr sz="1400" b="0" i="0">
+                          <a:solidFill>
+                            <a:srgbClr val="1A1A1A"/>
+                          </a:solidFill>
+                          <a:latin typeface="Meiryo UI"/>
+                        </a:rPr>
+                        <a:t>「会計×60超プロダクト×SaaS/Fintech/AI三層構造」は他SaaSと比較にならない複雑さ。前職スキルがそのまま通用せず得意な1-2商品に偏る</a:t>
                       </a:r>
                     </a:p>
                   </a:txBody>
@@ -4483,7 +4225,7 @@
                           </a:solidFill>
                           <a:latin typeface="Meiryo UI"/>
                         </a:rPr>
-                        <a:t>Salesforceあり・Excel併用</a:t>
+                        <a:t>Salesforce利用中・集計はExcel併用。「戦略と実行の断絶」セミナーに参加</a:t>
                       </a:r>
                     </a:p>
                   </a:txBody>
@@ -4506,7 +4248,7 @@
                           </a:solidFill>
                           <a:latin typeface="Meiryo UI"/>
                         </a:rPr>
-                        <a:t>介入ポイントが見えない。</a:t>
+                        <a:t>受注率低下の原因をデータで特定できず介入ポイントが見えない。</a:t>
                       </a:r>
                       <a:r>
                         <a:rPr sz="1400" b="0" i="0">
@@ -4515,7 +4257,30 @@
                           </a:solidFill>
                           <a:latin typeface="Meiryo UI"/>
                         </a:rPr>
-                        <a:t> フェーズ別受注率・担当者別分析不可。戦略はあるが実行を支える基盤がない</a:t>
+                        <a:t> 戦略は描けているが実行を支える基盤がない</a:t>
+                      </a:r>
+                    </a:p>
+                  </a:txBody>
+                  <a:tcPr>
+                    <a:solidFill>
+                      <a:srgbClr val="F5F7FA"/>
+                    </a:solidFill>
+                  </a:tcPr>
+                </a:tc>
+                <a:tc>
+                  <a:txBody>
+                    <a:bodyPr wrap="square"/>
+                    <a:lstStyle/>
+                    <a:p>
+                      <a:pPr algn="l"/>
+                      <a:r>
+                        <a:rPr sz="1400" b="0" i="0">
+                          <a:solidFill>
+                            <a:srgbClr val="1A1A1A"/>
+                          </a:solidFill>
+                          <a:latin typeface="Meiryo UI"/>
+                        </a:rPr>
+                        <a:t>フェーズ別受注率・リードソース別担当者別の分析が不可。Excel集計＝ドリルダウンできない＝PDCAが回せない</a:t>
                       </a:r>
                     </a:p>
                   </a:txBody>
@@ -4623,7 +4388,7 @@
                 </a:solidFill>
                 <a:latin typeface="Meiryo UI"/>
               </a:rPr>
-              <a:t>。戦略はあるが実行を支える基盤がない</a:t>
+              <a:t>。採用数に比例して売上が伸びる組織構造が実現できていない</a:t>
             </a:r>
           </a:p>
         </p:txBody>
@@ -4968,7 +4733,7 @@
                 </a:solidFill>
                 <a:latin typeface="Meiryo UI"/>
               </a:rPr>
-              <a:t>ASIS：3つの仮説障壁</a:t>
+              <a:t>ASIS：戦略推進にあたっての仮説障壁</a:t>
             </a:r>
           </a:p>
         </p:txBody>
@@ -5002,7 +4767,7 @@
                 </a:solidFill>
                 <a:latin typeface="Meiryo UI"/>
               </a:rPr>
-              <a:t>TOBE：3つの解決施策</a:t>
+              <a:t>TOBE：解決策・ご提案骨子</a:t>
             </a:r>
           </a:p>
         </p:txBody>
@@ -5125,7 +4890,7 @@
                 </a:solidFill>
                 <a:latin typeface="Meiryo UI"/>
               </a:rPr>
-              <a:t>提案の型なし→個人の商品知識に依存</a:t>
+              <a:t>「課題パターン×組み合わせ提案」の型がなく個人の商品知識に依存</a:t>
             </a:r>
           </a:p>
           <a:p>
@@ -5153,7 +4918,35 @@
                 </a:solidFill>
                 <a:latin typeface="Meiryo UI"/>
               </a:rPr>
-              <a:t>ヒアリング浅→機能売りに逃げる構造</a:t>
+              <a:t>ヒアリングが浅いまま提案に入り、機能売りに逃げる構造</a:t>
+            </a:r>
+          </a:p>
+          <a:p>
+            <a:pPr>
+              <a:spcBef>
+                <a:spcPts val="300"/>
+              </a:spcBef>
+              <a:spcAft>
+                <a:spcPts val="100"/>
+              </a:spcAft>
+            </a:pPr>
+            <a:r>
+              <a:rPr sz="1400" b="0" i="0">
+                <a:solidFill>
+                  <a:srgbClr val="888888"/>
+                </a:solidFill>
+                <a:latin typeface="Meiryo UI"/>
+              </a:rPr>
+              <a:t>      – </a:t>
+            </a:r>
+            <a:r>
+              <a:rPr sz="1400" b="0" i="0">
+                <a:solidFill>
+                  <a:srgbClr val="1A1A1A"/>
+                </a:solidFill>
+                <a:latin typeface="Meiryo UI"/>
+              </a:rPr>
+              <a:t>競合との機能比較→価格勝負に陥るケースが増加</a:t>
             </a:r>
           </a:p>
           <a:p>
@@ -5209,7 +5002,7 @@
                 </a:solidFill>
                 <a:latin typeface="Meiryo UI"/>
               </a:rPr>
-              <a:t>採用市場変化＋マネフォ固有の複雑さ</a:t>
+              <a:t>採用市場の構造変化×マネフォ固有の複雑さが重なる</a:t>
             </a:r>
           </a:p>
           <a:p>
@@ -5237,7 +5030,35 @@
                 </a:solidFill>
                 <a:latin typeface="Meiryo UI"/>
               </a:rPr>
-              <a:t>前職スキルが通用せず1-2商品に偏る</a:t>
+              <a:t>前職スキルが通用せず、得意な1-2商品に偏る</a:t>
+            </a:r>
+          </a:p>
+          <a:p>
+            <a:pPr>
+              <a:spcBef>
+                <a:spcPts val="300"/>
+              </a:spcBef>
+              <a:spcAft>
+                <a:spcPts val="100"/>
+              </a:spcAft>
+            </a:pPr>
+            <a:r>
+              <a:rPr sz="1400" b="0" i="0">
+                <a:solidFill>
+                  <a:srgbClr val="888888"/>
+                </a:solidFill>
+                <a:latin typeface="Meiryo UI"/>
+              </a:rPr>
+              <a:t>      – </a:t>
+            </a:r>
+            <a:r>
+              <a:rPr sz="1400" b="0" i="0">
+                <a:solidFill>
+                  <a:srgbClr val="1A1A1A"/>
+                </a:solidFill>
+                <a:latin typeface="Meiryo UI"/>
+              </a:rPr>
+              <a:t>採用数が増えても1人あたり売上が低下</a:t>
             </a:r>
           </a:p>
           <a:p>
@@ -5293,7 +5114,7 @@
                 </a:solidFill>
                 <a:latin typeface="Meiryo UI"/>
               </a:rPr>
-              <a:t>フェーズ別受注率が可視化されていない</a:t>
+              <a:t>どのフェーズで受注率が落ちているか可視化できていない</a:t>
             </a:r>
           </a:p>
           <a:p>
@@ -5321,7 +5142,35 @@
                 </a:solidFill>
                 <a:latin typeface="Meiryo UI"/>
               </a:rPr>
-              <a:t>Excel併用→PDCAが回せない</a:t>
+              <a:t>Excel集計＝ドリルダウン不可＝PDCAの回転が遅い</a:t>
+            </a:r>
+          </a:p>
+          <a:p>
+            <a:pPr>
+              <a:spcBef>
+                <a:spcPts val="300"/>
+              </a:spcBef>
+              <a:spcAft>
+                <a:spcPts val="100"/>
+              </a:spcAft>
+            </a:pPr>
+            <a:r>
+              <a:rPr sz="1400" b="0" i="0">
+                <a:solidFill>
+                  <a:srgbClr val="888888"/>
+                </a:solidFill>
+                <a:latin typeface="Meiryo UI"/>
+              </a:rPr>
+              <a:t>      – </a:t>
+            </a:r>
+            <a:r>
+              <a:rPr sz="1400" b="0" i="0">
+                <a:solidFill>
+                  <a:srgbClr val="1A1A1A"/>
+                </a:solidFill>
+                <a:latin typeface="Meiryo UI"/>
+              </a:rPr>
+              <a:t>営業企画として打ち手の判断材料がない</a:t>
             </a:r>
           </a:p>
         </p:txBody>
@@ -5400,7 +5249,7 @@
                 </a:solidFill>
                 <a:latin typeface="Meiryo UI"/>
               </a:rPr>
-              <a:t>カスタマーパスで「意思決定プロセス」に沿った提案型を実装</a:t>
+              <a:t>カスタマーパス設計：意思決定プロセスに沿ったヒアリングの型を実装</a:t>
             </a:r>
           </a:p>
           <a:p>
@@ -5428,7 +5277,35 @@
                 </a:solidFill>
                 <a:latin typeface="Meiryo UI"/>
               </a:rPr>
-              <a:t>中途でも型に沿えば最適提案が可能</a:t>
+              <a:t>ニーズマップ：課題パターン×プロダクト組み合わせを体系化</a:t>
+            </a:r>
+          </a:p>
+          <a:p>
+            <a:pPr>
+              <a:spcBef>
+                <a:spcPts val="300"/>
+              </a:spcBef>
+              <a:spcAft>
+                <a:spcPts val="100"/>
+              </a:spcAft>
+            </a:pPr>
+            <a:r>
+              <a:rPr sz="1400" b="0" i="0">
+                <a:solidFill>
+                  <a:srgbClr val="888888"/>
+                </a:solidFill>
+                <a:latin typeface="Meiryo UI"/>
+              </a:rPr>
+              <a:t>      – </a:t>
+            </a:r>
+            <a:r>
+              <a:rPr sz="1400" b="0" i="0">
+                <a:solidFill>
+                  <a:srgbClr val="1A1A1A"/>
+                </a:solidFill>
+                <a:latin typeface="Meiryo UI"/>
+              </a:rPr>
+              <a:t>中途でも型に沿えば最適提案が可能に</a:t>
             </a:r>
           </a:p>
           <a:p>
@@ -5512,7 +5389,35 @@
                 </a:solidFill>
                 <a:latin typeface="Meiryo UI"/>
               </a:rPr>
-              <a:t>Excel撤廃→営業企画がデータで介入判断</a:t>
+              <a:t>リードソース×担当者別のドリルダウン分析</a:t>
+            </a:r>
+          </a:p>
+          <a:p>
+            <a:pPr>
+              <a:spcBef>
+                <a:spcPts val="300"/>
+              </a:spcBef>
+              <a:spcAft>
+                <a:spcPts val="100"/>
+              </a:spcAft>
+            </a:pPr>
+            <a:r>
+              <a:rPr sz="1400" b="0" i="0">
+                <a:solidFill>
+                  <a:srgbClr val="888888"/>
+                </a:solidFill>
+                <a:latin typeface="Meiryo UI"/>
+              </a:rPr>
+              <a:t>      – </a:t>
+            </a:r>
+            <a:r>
+              <a:rPr sz="1400" b="0" i="0">
+                <a:solidFill>
+                  <a:srgbClr val="1A1A1A"/>
+                </a:solidFill>
+                <a:latin typeface="Meiryo UI"/>
+              </a:rPr>
+              <a:t>Excel撤廃→営業企画がデータで即時介入</a:t>
             </a:r>
           </a:p>
           <a:p>
@@ -5541,6 +5446,34 @@
                 <a:latin typeface="Meiryo UI"/>
               </a:rPr>
               <a:t>Buddy伴走：戦略と実行の断絶を埋める</a:t>
+            </a:r>
+          </a:p>
+          <a:p>
+            <a:pPr>
+              <a:spcBef>
+                <a:spcPts val="300"/>
+              </a:spcBef>
+              <a:spcAft>
+                <a:spcPts val="100"/>
+              </a:spcAft>
+            </a:pPr>
+            <a:r>
+              <a:rPr sz="1400" b="0" i="0">
+                <a:solidFill>
+                  <a:srgbClr val="888888"/>
+                </a:solidFill>
+                <a:latin typeface="Meiryo UI"/>
+              </a:rPr>
+              <a:t>      – </a:t>
+            </a:r>
+            <a:r>
+              <a:rPr sz="1400" b="0" i="0">
+                <a:solidFill>
+                  <a:srgbClr val="1A1A1A"/>
+                </a:solidFill>
+                <a:latin typeface="Meiryo UI"/>
+              </a:rPr>
+              <a:t>朝会夕会の運用設計×専任Buddy伴走で行動変容を支援</a:t>
             </a:r>
           </a:p>
           <a:p>
@@ -5685,7 +5618,7 @@
                 </a:solidFill>
                 <a:latin typeface="Meiryo UI"/>
               </a:rPr>
-              <a:t> 営業の型の可視化（カスタマーパス作成）＋ データ基盤で介入ポイントを可視化</a:t>
+              <a:t> 営業の型の可視化（カスタマーパス＋ニーズマップ作成）＋ データ基盤で介入ポイントを可視化</a:t>
             </a:r>
           </a:p>
         </p:txBody>

</xml_diff>